<commit_message>
Re-layout CV slide 2 (CSL internship) into two sections
Start from the user's latest edited deck; only slide 2 changes.
- Split the internship into numbered sections: 01 OpenArm imitation
  learning (text + sim replay image) and 02 UMI gripper design
  (gripper photo + text, mirrored layout).
- Drop the text step row that duplicated the pipeline screenshot figure;
  keep the figure centred with the demo link restyled as its caption.
- Move the closing reflection into a tinted callout and fix the bottom
  captions that collided with the page number.
- Body text at 10.5pt to match the other project pages.

Co-Authored-By: Claude Opus 5.5 <noreply@anthropic.com>
Claude-Session: https://claude.ai/code/session_01X2qFQGQaWjMneKihQ62xc2
</commit_message>
<xml_diff>
--- a/CV_updated.pptx
+++ b/CV_updated.pptx
@@ -10,7 +10,7 @@
   <p:sldIdLst>
     <p:sldId id="256" r:id="rId2"/>
     <p:sldId id="257" r:id="rId3"/>
-    <p:sldId id="258" r:id="rId4"/>
+    <p:sldId id="262" r:id="rId4"/>
     <p:sldId id="259" r:id="rId5"/>
     <p:sldId id="260" r:id="rId6"/>
     <p:sldId id="261" r:id="rId7"/>
@@ -2393,7 +2393,29 @@
                 <a:ea typeface="Microsoft JhengHei" pitchFamily="34" charset="-120"/>
                 <a:cs typeface="Microsoft JhengHei" pitchFamily="34" charset="-120"/>
               </a:rPr>
-              <a:t>在 OpenArm 雙臂上用模仿學習做雙手交接任務，接 VR 遙操作錄示範，再用資料擴增補足訓練資料</a:t>
+              <a:t>在 OpenArm 雙臂上用模仿學習做雙手交接任務，串接 VR 於</a:t>
+            </a:r>
+            <a:r>
+              <a:rPr lang="en-US" altLang="zh-TW" sz="1050" dirty="0">
+                <a:solidFill>
+                  <a:srgbClr val="1F2933"/>
+                </a:solidFill>
+                <a:latin typeface="Microsoft JhengHei" pitchFamily="34" charset="0"/>
+                <a:ea typeface="Microsoft JhengHei" pitchFamily="34" charset="-120"/>
+                <a:cs typeface="Microsoft JhengHei" pitchFamily="34" charset="-120"/>
+              </a:rPr>
+              <a:t>Isaac Sim</a:t>
+            </a:r>
+            <a:r>
+              <a:rPr lang="zh-TW" altLang="en-US" sz="1050" dirty="0">
+                <a:solidFill>
+                  <a:srgbClr val="1F2933"/>
+                </a:solidFill>
+                <a:latin typeface="Microsoft JhengHei" pitchFamily="34" charset="0"/>
+                <a:ea typeface="Microsoft JhengHei" pitchFamily="34" charset="-120"/>
+                <a:cs typeface="Microsoft JhengHei" pitchFamily="34" charset="-120"/>
+              </a:rPr>
+              <a:t>遙操作錄示範，再用資料擴增補足訓練資料</a:t>
             </a:r>
             <a:endParaRPr lang="zh-TW" altLang="en-US" sz="1050" dirty="0"/>
           </a:p>
@@ -2417,7 +2439,7 @@
                 <a:ea typeface="Microsoft JhengHei" pitchFamily="34" charset="-120"/>
                 <a:cs typeface="Microsoft JhengHei" pitchFamily="34" charset="-120"/>
               </a:rPr>
-              <a:t>設計給 UMI 使用的夾爪，3D 列印反覆修改後，裝到雙足機器人的手臂末端</a:t>
+              <a:t>設計給 UMI 使用的夾爪，3D 列印反覆修改後，裝至雙足機器人的手臂末端</a:t>
             </a:r>
             <a:endParaRPr lang="zh-TW" altLang="en-US" sz="1050" dirty="0"/>
           </a:p>
@@ -2577,6 +2599,17 @@
               </a:rPr>
               <a:t>2025</a:t>
             </a:r>
+            <a:r>
+              <a:rPr lang="en-US" altLang="zh-TW" sz="950" dirty="0">
+                <a:solidFill>
+                  <a:srgbClr val="5F6B7A"/>
+                </a:solidFill>
+                <a:latin typeface="Microsoft JhengHei" pitchFamily="34" charset="0"/>
+                <a:ea typeface="Microsoft JhengHei" pitchFamily="34" charset="-120"/>
+                <a:cs typeface="Microsoft JhengHei" pitchFamily="34" charset="-120"/>
+              </a:rPr>
+              <a:t>.07-12</a:t>
+            </a:r>
             <a:endParaRPr lang="zh-TW" altLang="en-US" sz="950" dirty="0"/>
           </a:p>
         </p:txBody>
@@ -2614,7 +2647,7 @@
                 <a:ea typeface="Microsoft JhengHei" pitchFamily="34" charset="-120"/>
                 <a:cs typeface="Microsoft JhengHei" pitchFamily="34" charset="-120"/>
               </a:rPr>
-              <a:t>隊長  ·  機構與電路設計</a:t>
+              <a:t>機構與電路設計</a:t>
             </a:r>
             <a:endParaRPr lang="zh-TW" altLang="en-US" sz="1000" dirty="0"/>
           </a:p>
@@ -2684,7 +2717,7 @@
                 <a:ea typeface="Microsoft JhengHei" pitchFamily="34" charset="-120"/>
                 <a:cs typeface="Microsoft JhengHei" pitchFamily="34" charset="-120"/>
               </a:rPr>
-              <a:t>射擊初速 12–15 m/s，獲創意技術獎特優</a:t>
+              <a:t>獲創意技術獎特優</a:t>
             </a:r>
             <a:endParaRPr lang="zh-TW" altLang="en-US" sz="1050" dirty="0"/>
           </a:p>
@@ -2762,7 +2795,29 @@
                 <a:ea typeface="Microsoft JhengHei" pitchFamily="34" charset="-120"/>
                 <a:cs typeface="Microsoft JhengHei" pitchFamily="34" charset="-120"/>
               </a:rPr>
-              <a:t>清華大學</a:t>
+              <a:t>清大</a:t>
+            </a:r>
+            <a:r>
+              <a:rPr lang="en-US" altLang="zh-TW" sz="950" dirty="0">
+                <a:solidFill>
+                  <a:srgbClr val="5F6B7A"/>
+                </a:solidFill>
+                <a:latin typeface="Microsoft JhengHei" pitchFamily="34" charset="0"/>
+                <a:ea typeface="Microsoft JhengHei" pitchFamily="34" charset="-120"/>
+                <a:cs typeface="Microsoft JhengHei" pitchFamily="34" charset="-120"/>
+              </a:rPr>
+              <a:t>AI</a:t>
+            </a:r>
+            <a:r>
+              <a:rPr lang="zh-TW" altLang="en-US" sz="950" dirty="0">
+                <a:solidFill>
+                  <a:srgbClr val="5F6B7A"/>
+                </a:solidFill>
+                <a:latin typeface="Microsoft JhengHei" pitchFamily="34" charset="0"/>
+                <a:ea typeface="Microsoft JhengHei" pitchFamily="34" charset="-120"/>
+                <a:cs typeface="Microsoft JhengHei" pitchFamily="34" charset="-120"/>
+              </a:rPr>
+              <a:t> 聯盟課程</a:t>
             </a:r>
             <a:endParaRPr lang="zh-TW" altLang="en-US" sz="950" dirty="0"/>
           </a:p>
@@ -2808,7 +2863,7 @@
                 <a:ea typeface="Microsoft JhengHei" pitchFamily="34" charset="-120"/>
                 <a:cs typeface="Microsoft JhengHei" pitchFamily="34" charset="-120"/>
               </a:rPr>
-              <a:t>實作 A*、RRT* 路徑規劃和 Stanley、LQR 軌跡追蹤，也做了 ROS 2 節點通訊和強化學習的練習</a:t>
+              <a:t>實作 A*、RRT* 路徑規劃和 Stanley、LQR 軌跡追蹤，也實做 ROS 2 節點通訊和強化學習的練習</a:t>
             </a:r>
             <a:endParaRPr lang="zh-TW" altLang="en-US" sz="1050" dirty="0"/>
           </a:p>
@@ -3959,87 +4014,14 @@
       </p:sp>
       <p:sp>
         <p:nvSpPr>
-          <p:cNvPr id="23" name="Shape 21"/>
-          <p:cNvSpPr/>
-          <p:nvPr/>
-        </p:nvSpPr>
-        <p:spPr>
-          <a:xfrm>
-            <a:off x="6359652" y="1956816"/>
-            <a:ext cx="612648" cy="246888"/>
-          </a:xfrm>
-          <a:prstGeom prst="roundRect">
-            <a:avLst>
-              <a:gd name="adj" fmla="val 22222"/>
-            </a:avLst>
-          </a:prstGeom>
-          <a:solidFill>
-            <a:srgbClr val="E3EAF3"/>
-          </a:solidFill>
-          <a:ln w="12700">
-            <a:solidFill>
-              <a:srgbClr val="E3EAF3"/>
-            </a:solidFill>
-            <a:prstDash val="solid"/>
-          </a:ln>
-        </p:spPr>
-        <p:txBody>
-          <a:bodyPr/>
-          <a:lstStyle/>
-          <a:p>
-            <a:endParaRPr lang="zh-TW" altLang="en-US"/>
-          </a:p>
-        </p:txBody>
-      </p:sp>
-      <p:sp>
-        <p:nvSpPr>
-          <p:cNvPr id="24" name="Text 22"/>
-          <p:cNvSpPr txBox="1"/>
-          <p:nvPr/>
-        </p:nvSpPr>
-        <p:spPr>
-          <a:xfrm>
-            <a:off x="6359652" y="1956816"/>
-            <a:ext cx="612648" cy="246888"/>
-          </a:xfrm>
-          <a:prstGeom prst="rect">
-            <a:avLst/>
-          </a:prstGeom>
-          <a:noFill/>
-          <a:ln/>
-        </p:spPr>
-        <p:txBody>
-          <a:bodyPr wrap="square" lIns="0" tIns="0" rIns="0" bIns="0" rtlCol="0" anchor="ctr"/>
-          <a:lstStyle/>
-          <a:p>
-            <a:pPr marL="0" indent="0" algn="ctr" eaLnBrk="1" latinLnBrk="0" hangingPunct="1">
-              <a:buNone/>
-            </a:pPr>
-            <a:r>
-              <a:rPr lang="zh-TW" altLang="en-US" sz="900" dirty="0">
-                <a:solidFill>
-                  <a:srgbClr val="1F3A5F"/>
-                </a:solidFill>
-                <a:latin typeface="Microsoft JhengHei" pitchFamily="34" charset="0"/>
-                <a:ea typeface="Microsoft JhengHei" pitchFamily="34" charset="-120"/>
-                <a:cs typeface="Microsoft JhengHei" pitchFamily="34" charset="-120"/>
-              </a:rPr>
-              <a:t>3D 列印</a:t>
-            </a:r>
-            <a:endParaRPr lang="zh-TW" altLang="en-US" sz="900" dirty="0"/>
-          </a:p>
-        </p:txBody>
-      </p:sp>
-      <p:sp>
-        <p:nvSpPr>
           <p:cNvPr id="25" name="P2_a"/>
           <p:cNvSpPr txBox="1"/>
           <p:nvPr/>
         </p:nvSpPr>
         <p:spPr>
           <a:xfrm>
-            <a:off x="548640" y="2496312"/>
-            <a:ext cx="6459322" cy="735178"/>
+            <a:off x="548640" y="2359152"/>
+            <a:ext cx="6455664" cy="475488"/>
           </a:xfrm>
           <a:prstGeom prst="rect">
             <a:avLst/>
@@ -4061,7 +4043,7 @@
               <a:buNone/>
             </a:pPr>
             <a:r>
-              <a:rPr lang="zh-TW" altLang="en-US" sz="1100" dirty="0">
+              <a:rPr lang="zh-TW" altLang="en-US" sz="1050" dirty="0">
                 <a:solidFill>
                   <a:srgbClr val="1F2933"/>
                 </a:solidFill>
@@ -4069,576 +4051,22 @@
                 <a:ea typeface="Microsoft JhengHei" pitchFamily="34" charset="-120"/>
                 <a:cs typeface="Microsoft JhengHei" pitchFamily="34" charset="-120"/>
               </a:rPr>
-              <a:t>在 CSL 的兩個月，一開始在 MuJoCo 裡學機械手臂的基礎：工作空間、動力學和阻抗力矩補償，接著在實體手臂上做 system ID，然後投入兩個專案。</a:t>
-            </a:r>
-            <a:endParaRPr lang="zh-TW" altLang="en-US" sz="1100" dirty="0"/>
-          </a:p>
-          <a:p>
-            <a:pPr marL="0" indent="0" eaLnBrk="1" latinLnBrk="0" hangingPunct="1">
-              <a:lnSpc>
-                <a:spcPct val="130000"/>
-              </a:lnSpc>
-              <a:spcAft>
-                <a:spcPts val="500"/>
-              </a:spcAft>
-              <a:buNone/>
-            </a:pPr>
-            <a:r>
-              <a:rPr lang="zh-TW" altLang="en-US" sz="1100" b="1" dirty="0">
-                <a:solidFill>
-                  <a:srgbClr val="1F3A5F"/>
-                </a:solidFill>
-                <a:latin typeface="Microsoft JhengHei" pitchFamily="34" charset="0"/>
-                <a:ea typeface="Microsoft JhengHei" pitchFamily="34" charset="-120"/>
-                <a:cs typeface="Microsoft JhengHei" pitchFamily="34" charset="-120"/>
-              </a:rPr>
-              <a:t>一、OpenArm 雙臂模仿學習：</a:t>
-            </a:r>
-            <a:r>
-              <a:rPr lang="zh-TW" altLang="en-US" sz="1100" dirty="0">
-                <a:solidFill>
-                  <a:srgbClr val="1F2933"/>
-                </a:solidFill>
-                <a:latin typeface="Microsoft JhengHei" pitchFamily="34" charset="0"/>
-                <a:ea typeface="Microsoft JhengHei" pitchFamily="34" charset="-120"/>
-                <a:cs typeface="Microsoft JhengHei" pitchFamily="34" charset="-120"/>
-              </a:rPr>
-              <a:t>考量時間和成本，我選擇用資料擴增來做雙手交接任務，流程如下：</a:t>
-            </a:r>
-            <a:endParaRPr lang="zh-TW" altLang="en-US" sz="1100" dirty="0"/>
-          </a:p>
-        </p:txBody>
-      </p:sp>
-      <p:sp>
-        <p:nvSpPr>
-          <p:cNvPr id="26" name="Shape 24"/>
+              <a:t>在 CSL 的兩個月，一開始在 MuJoCo 裡學機械手臂的基礎：工作空間、動力學和阻抗力矩補償，接著在實體手臂上做 system ID，然後投入下面兩個專案。</a:t>
+            </a:r>
+            <a:endParaRPr lang="zh-TW" altLang="en-US" sz="1050" dirty="0"/>
+          </a:p>
+        </p:txBody>
+      </p:sp>
+      <p:sp>
+        <p:nvSpPr>
+          <p:cNvPr id="53" name="S1 badge"/>
           <p:cNvSpPr/>
           <p:nvPr/>
         </p:nvSpPr>
         <p:spPr>
           <a:xfrm>
-            <a:off x="548640" y="3286354"/>
-            <a:ext cx="1130930" cy="548640"/>
-          </a:xfrm>
-          <a:prstGeom prst="roundRect">
-            <a:avLst>
-              <a:gd name="adj" fmla="val 11667"/>
-            </a:avLst>
-          </a:prstGeom>
-          <a:solidFill>
-            <a:srgbClr val="EEF2F7"/>
-          </a:solidFill>
-          <a:ln w="9525">
-            <a:solidFill>
-              <a:srgbClr val="C9D1DC"/>
-            </a:solidFill>
-            <a:prstDash val="solid"/>
-          </a:ln>
-        </p:spPr>
-        <p:txBody>
-          <a:bodyPr/>
-          <a:lstStyle/>
-          <a:p>
-            <a:endParaRPr lang="zh-TW" altLang="en-US"/>
-          </a:p>
-        </p:txBody>
-      </p:sp>
-      <p:sp>
-        <p:nvSpPr>
-          <p:cNvPr id="27" name="Text 25"/>
-          <p:cNvSpPr txBox="1"/>
-          <p:nvPr/>
-        </p:nvSpPr>
-        <p:spPr>
-          <a:xfrm>
-            <a:off x="548640" y="3286354"/>
-            <a:ext cx="1130930" cy="548640"/>
-          </a:xfrm>
-          <a:prstGeom prst="rect">
-            <a:avLst/>
-          </a:prstGeom>
-          <a:noFill/>
-          <a:ln/>
-        </p:spPr>
-        <p:txBody>
-          <a:bodyPr wrap="square" lIns="0" tIns="0" rIns="0" bIns="0" rtlCol="0" anchor="ctr"/>
-          <a:lstStyle/>
-          <a:p>
-            <a:pPr marL="0" indent="0" algn="ctr" eaLnBrk="1" latinLnBrk="0" hangingPunct="1">
-              <a:lnSpc>
-                <a:spcPct val="105000"/>
-              </a:lnSpc>
-              <a:buNone/>
-            </a:pPr>
-            <a:r>
-              <a:rPr lang="zh-TW" altLang="en-US" sz="950" b="1" dirty="0">
-                <a:solidFill>
-                  <a:srgbClr val="1F3A5F"/>
-                </a:solidFill>
-                <a:latin typeface="Microsoft JhengHei" pitchFamily="34" charset="0"/>
-                <a:ea typeface="Microsoft JhengHei" pitchFamily="34" charset="-120"/>
-                <a:cs typeface="Microsoft JhengHei" pitchFamily="34" charset="-120"/>
-              </a:rPr>
-              <a:t>遙操作示範</a:t>
-            </a:r>
-            <a:endParaRPr lang="zh-TW" altLang="en-US" sz="950" dirty="0"/>
-          </a:p>
-        </p:txBody>
-      </p:sp>
-      <p:sp>
-        <p:nvSpPr>
-          <p:cNvPr id="28" name="Text 26"/>
-          <p:cNvSpPr txBox="1"/>
-          <p:nvPr/>
-        </p:nvSpPr>
-        <p:spPr>
-          <a:xfrm>
-            <a:off x="1679570" y="3286354"/>
-            <a:ext cx="201168" cy="548640"/>
-          </a:xfrm>
-          <a:prstGeom prst="rect">
-            <a:avLst/>
-          </a:prstGeom>
-          <a:noFill/>
-          <a:ln/>
-        </p:spPr>
-        <p:txBody>
-          <a:bodyPr wrap="square" lIns="0" tIns="0" rIns="0" bIns="0" rtlCol="0" anchor="ctr"/>
-          <a:lstStyle/>
-          <a:p>
-            <a:pPr marL="0" indent="0" algn="ctr" eaLnBrk="1" latinLnBrk="0" hangingPunct="1">
-              <a:buNone/>
-            </a:pPr>
-            <a:r>
-              <a:rPr lang="zh-TW" altLang="en-US" sz="1600" dirty="0">
-                <a:solidFill>
-                  <a:srgbClr val="5F6B7A"/>
-                </a:solidFill>
-                <a:latin typeface="Microsoft JhengHei" pitchFamily="34" charset="0"/>
-                <a:ea typeface="Microsoft JhengHei" pitchFamily="34" charset="-120"/>
-                <a:cs typeface="Microsoft JhengHei" pitchFamily="34" charset="-120"/>
-              </a:rPr>
-              <a:t>›</a:t>
-            </a:r>
-            <a:endParaRPr lang="zh-TW" altLang="en-US" sz="1600" dirty="0"/>
-          </a:p>
-        </p:txBody>
-      </p:sp>
-      <p:sp>
-        <p:nvSpPr>
-          <p:cNvPr id="29" name="Shape 27"/>
-          <p:cNvSpPr/>
-          <p:nvPr/>
-        </p:nvSpPr>
-        <p:spPr>
-          <a:xfrm>
-            <a:off x="1880738" y="3286354"/>
-            <a:ext cx="1130930" cy="548640"/>
-          </a:xfrm>
-          <a:prstGeom prst="roundRect">
-            <a:avLst>
-              <a:gd name="adj" fmla="val 11667"/>
-            </a:avLst>
-          </a:prstGeom>
-          <a:solidFill>
-            <a:srgbClr val="EEF2F7"/>
-          </a:solidFill>
-          <a:ln w="9525">
-            <a:solidFill>
-              <a:srgbClr val="C9D1DC"/>
-            </a:solidFill>
-            <a:prstDash val="solid"/>
-          </a:ln>
-        </p:spPr>
-        <p:txBody>
-          <a:bodyPr/>
-          <a:lstStyle/>
-          <a:p>
-            <a:endParaRPr lang="zh-TW" altLang="en-US"/>
-          </a:p>
-        </p:txBody>
-      </p:sp>
-      <p:sp>
-        <p:nvSpPr>
-          <p:cNvPr id="30" name="Text 28"/>
-          <p:cNvSpPr txBox="1"/>
-          <p:nvPr/>
-        </p:nvSpPr>
-        <p:spPr>
-          <a:xfrm>
-            <a:off x="1880738" y="3286354"/>
-            <a:ext cx="1130930" cy="548640"/>
-          </a:xfrm>
-          <a:prstGeom prst="rect">
-            <a:avLst/>
-          </a:prstGeom>
-          <a:noFill/>
-          <a:ln/>
-        </p:spPr>
-        <p:txBody>
-          <a:bodyPr wrap="square" lIns="0" tIns="0" rIns="0" bIns="0" rtlCol="0" anchor="ctr"/>
-          <a:lstStyle/>
-          <a:p>
-            <a:pPr marL="0" indent="0" algn="ctr" eaLnBrk="1" latinLnBrk="0" hangingPunct="1">
-              <a:lnSpc>
-                <a:spcPct val="105000"/>
-              </a:lnSpc>
-              <a:buNone/>
-            </a:pPr>
-            <a:r>
-              <a:rPr lang="zh-TW" altLang="en-US" sz="950" b="1" dirty="0">
-                <a:solidFill>
-                  <a:srgbClr val="1F3A5F"/>
-                </a:solidFill>
-                <a:latin typeface="Microsoft JhengHei" pitchFamily="34" charset="0"/>
-                <a:ea typeface="Microsoft JhengHei" pitchFamily="34" charset="-120"/>
-                <a:cs typeface="Microsoft JhengHei" pitchFamily="34" charset="-120"/>
-              </a:rPr>
-              <a:t>Isaac Lab Mimic</a:t>
-            </a:r>
-            <a:endParaRPr lang="zh-TW" altLang="en-US" sz="950" dirty="0"/>
-          </a:p>
-          <a:p>
-            <a:pPr marL="0" indent="0" algn="ctr" eaLnBrk="1" latinLnBrk="0" hangingPunct="1">
-              <a:lnSpc>
-                <a:spcPct val="105000"/>
-              </a:lnSpc>
-              <a:buNone/>
-            </a:pPr>
-            <a:r>
-              <a:rPr lang="zh-TW" altLang="en-US" sz="950" b="1" dirty="0">
-                <a:solidFill>
-                  <a:srgbClr val="1F3A5F"/>
-                </a:solidFill>
-                <a:latin typeface="Microsoft JhengHei" pitchFamily="34" charset="0"/>
-                <a:ea typeface="Microsoft JhengHei" pitchFamily="34" charset="-120"/>
-                <a:cs typeface="Microsoft JhengHei" pitchFamily="34" charset="-120"/>
-              </a:rPr>
-              <a:t>資料擴增</a:t>
-            </a:r>
-            <a:endParaRPr lang="zh-TW" altLang="en-US" sz="950" dirty="0"/>
-          </a:p>
-        </p:txBody>
-      </p:sp>
-      <p:sp>
-        <p:nvSpPr>
-          <p:cNvPr id="31" name="Text 29"/>
-          <p:cNvSpPr txBox="1"/>
-          <p:nvPr/>
-        </p:nvSpPr>
-        <p:spPr>
-          <a:xfrm>
-            <a:off x="3011668" y="3286354"/>
-            <a:ext cx="201168" cy="548640"/>
-          </a:xfrm>
-          <a:prstGeom prst="rect">
-            <a:avLst/>
-          </a:prstGeom>
-          <a:noFill/>
-          <a:ln/>
-        </p:spPr>
-        <p:txBody>
-          <a:bodyPr wrap="square" lIns="0" tIns="0" rIns="0" bIns="0" rtlCol="0" anchor="ctr"/>
-          <a:lstStyle/>
-          <a:p>
-            <a:pPr marL="0" indent="0" algn="ctr" eaLnBrk="1" latinLnBrk="0" hangingPunct="1">
-              <a:buNone/>
-            </a:pPr>
-            <a:r>
-              <a:rPr lang="zh-TW" altLang="en-US" sz="1600" dirty="0">
-                <a:solidFill>
-                  <a:srgbClr val="5F6B7A"/>
-                </a:solidFill>
-                <a:latin typeface="Microsoft JhengHei" pitchFamily="34" charset="0"/>
-                <a:ea typeface="Microsoft JhengHei" pitchFamily="34" charset="-120"/>
-                <a:cs typeface="Microsoft JhengHei" pitchFamily="34" charset="-120"/>
-              </a:rPr>
-              <a:t>›</a:t>
-            </a:r>
-            <a:endParaRPr lang="zh-TW" altLang="en-US" sz="1600" dirty="0"/>
-          </a:p>
-        </p:txBody>
-      </p:sp>
-      <p:sp>
-        <p:nvSpPr>
-          <p:cNvPr id="32" name="Shape 30"/>
-          <p:cNvSpPr/>
-          <p:nvPr/>
-        </p:nvSpPr>
-        <p:spPr>
-          <a:xfrm>
-            <a:off x="3212836" y="3286354"/>
-            <a:ext cx="1130930" cy="548640"/>
-          </a:xfrm>
-          <a:prstGeom prst="roundRect">
-            <a:avLst>
-              <a:gd name="adj" fmla="val 11667"/>
-            </a:avLst>
-          </a:prstGeom>
-          <a:solidFill>
-            <a:srgbClr val="EEF2F7"/>
-          </a:solidFill>
-          <a:ln w="9525">
-            <a:solidFill>
-              <a:srgbClr val="C9D1DC"/>
-            </a:solidFill>
-            <a:prstDash val="solid"/>
-          </a:ln>
-        </p:spPr>
-        <p:txBody>
-          <a:bodyPr/>
-          <a:lstStyle/>
-          <a:p>
-            <a:endParaRPr lang="zh-TW" altLang="en-US"/>
-          </a:p>
-        </p:txBody>
-      </p:sp>
-      <p:sp>
-        <p:nvSpPr>
-          <p:cNvPr id="33" name="Text 31"/>
-          <p:cNvSpPr txBox="1"/>
-          <p:nvPr/>
-        </p:nvSpPr>
-        <p:spPr>
-          <a:xfrm>
-            <a:off x="3212836" y="3286354"/>
-            <a:ext cx="1130930" cy="548640"/>
-          </a:xfrm>
-          <a:prstGeom prst="rect">
-            <a:avLst/>
-          </a:prstGeom>
-          <a:noFill/>
-          <a:ln/>
-        </p:spPr>
-        <p:txBody>
-          <a:bodyPr wrap="square" lIns="0" tIns="0" rIns="0" bIns="0" rtlCol="0" anchor="ctr"/>
-          <a:lstStyle/>
-          <a:p>
-            <a:pPr marL="0" indent="0" algn="ctr" eaLnBrk="1" latinLnBrk="0" hangingPunct="1">
-              <a:lnSpc>
-                <a:spcPct val="105000"/>
-              </a:lnSpc>
-              <a:buNone/>
-            </a:pPr>
-            <a:r>
-              <a:rPr lang="zh-TW" altLang="en-US" sz="950" b="1" dirty="0">
-                <a:solidFill>
-                  <a:srgbClr val="1F3A5F"/>
-                </a:solidFill>
-                <a:latin typeface="Microsoft JhengHei" pitchFamily="34" charset="0"/>
-                <a:ea typeface="Microsoft JhengHei" pitchFamily="34" charset="-120"/>
-                <a:cs typeface="Microsoft JhengHei" pitchFamily="34" charset="-120"/>
-              </a:rPr>
-              <a:t>LeRobot</a:t>
-            </a:r>
-            <a:endParaRPr lang="zh-TW" altLang="en-US" sz="950" dirty="0"/>
-          </a:p>
-          <a:p>
-            <a:pPr marL="0" indent="0" algn="ctr" eaLnBrk="1" latinLnBrk="0" hangingPunct="1">
-              <a:lnSpc>
-                <a:spcPct val="105000"/>
-              </a:lnSpc>
-              <a:buNone/>
-            </a:pPr>
-            <a:r>
-              <a:rPr lang="zh-TW" altLang="en-US" sz="950" b="1" dirty="0">
-                <a:solidFill>
-                  <a:srgbClr val="1F3A5F"/>
-                </a:solidFill>
-                <a:latin typeface="Microsoft JhengHei" pitchFamily="34" charset="0"/>
-                <a:ea typeface="Microsoft JhengHei" pitchFamily="34" charset="-120"/>
-                <a:cs typeface="Microsoft JhengHei" pitchFamily="34" charset="-120"/>
-              </a:rPr>
-              <a:t>資料集</a:t>
-            </a:r>
-            <a:endParaRPr lang="zh-TW" altLang="en-US" sz="950" dirty="0"/>
-          </a:p>
-        </p:txBody>
-      </p:sp>
-      <p:sp>
-        <p:nvSpPr>
-          <p:cNvPr id="34" name="Text 32"/>
-          <p:cNvSpPr txBox="1"/>
-          <p:nvPr/>
-        </p:nvSpPr>
-        <p:spPr>
-          <a:xfrm>
-            <a:off x="4343766" y="3286354"/>
-            <a:ext cx="201168" cy="548640"/>
-          </a:xfrm>
-          <a:prstGeom prst="rect">
-            <a:avLst/>
-          </a:prstGeom>
-          <a:noFill/>
-          <a:ln/>
-        </p:spPr>
-        <p:txBody>
-          <a:bodyPr wrap="square" lIns="0" tIns="0" rIns="0" bIns="0" rtlCol="0" anchor="ctr"/>
-          <a:lstStyle/>
-          <a:p>
-            <a:pPr marL="0" indent="0" algn="ctr" eaLnBrk="1" latinLnBrk="0" hangingPunct="1">
-              <a:buNone/>
-            </a:pPr>
-            <a:r>
-              <a:rPr lang="zh-TW" altLang="en-US" sz="1600" dirty="0">
-                <a:solidFill>
-                  <a:srgbClr val="5F6B7A"/>
-                </a:solidFill>
-                <a:latin typeface="Microsoft JhengHei" pitchFamily="34" charset="0"/>
-                <a:ea typeface="Microsoft JhengHei" pitchFamily="34" charset="-120"/>
-                <a:cs typeface="Microsoft JhengHei" pitchFamily="34" charset="-120"/>
-              </a:rPr>
-              <a:t>›</a:t>
-            </a:r>
-            <a:endParaRPr lang="zh-TW" altLang="en-US" sz="1600" dirty="0"/>
-          </a:p>
-        </p:txBody>
-      </p:sp>
-      <p:sp>
-        <p:nvSpPr>
-          <p:cNvPr id="35" name="Shape 33"/>
-          <p:cNvSpPr/>
-          <p:nvPr/>
-        </p:nvSpPr>
-        <p:spPr>
-          <a:xfrm>
-            <a:off x="4544934" y="3286354"/>
-            <a:ext cx="1130930" cy="548640"/>
-          </a:xfrm>
-          <a:prstGeom prst="roundRect">
-            <a:avLst>
-              <a:gd name="adj" fmla="val 11667"/>
-            </a:avLst>
-          </a:prstGeom>
-          <a:solidFill>
-            <a:srgbClr val="EEF2F7"/>
-          </a:solidFill>
-          <a:ln w="9525">
-            <a:solidFill>
-              <a:srgbClr val="C9D1DC"/>
-            </a:solidFill>
-            <a:prstDash val="solid"/>
-          </a:ln>
-        </p:spPr>
-        <p:txBody>
-          <a:bodyPr/>
-          <a:lstStyle/>
-          <a:p>
-            <a:endParaRPr lang="zh-TW" altLang="en-US"/>
-          </a:p>
-        </p:txBody>
-      </p:sp>
-      <p:sp>
-        <p:nvSpPr>
-          <p:cNvPr id="36" name="Text 34"/>
-          <p:cNvSpPr txBox="1"/>
-          <p:nvPr/>
-        </p:nvSpPr>
-        <p:spPr>
-          <a:xfrm>
-            <a:off x="4544934" y="3286354"/>
-            <a:ext cx="1130930" cy="548640"/>
-          </a:xfrm>
-          <a:prstGeom prst="rect">
-            <a:avLst/>
-          </a:prstGeom>
-          <a:noFill/>
-          <a:ln/>
-        </p:spPr>
-        <p:txBody>
-          <a:bodyPr wrap="square" lIns="0" tIns="0" rIns="0" bIns="0" rtlCol="0" anchor="ctr"/>
-          <a:lstStyle/>
-          <a:p>
-            <a:pPr marL="0" indent="0" algn="ctr" eaLnBrk="1" latinLnBrk="0" hangingPunct="1">
-              <a:lnSpc>
-                <a:spcPct val="105000"/>
-              </a:lnSpc>
-              <a:buNone/>
-            </a:pPr>
-            <a:r>
-              <a:rPr lang="zh-TW" altLang="en-US" sz="950" b="1" dirty="0">
-                <a:solidFill>
-                  <a:srgbClr val="1F3A5F"/>
-                </a:solidFill>
-                <a:latin typeface="Microsoft JhengHei" pitchFamily="34" charset="0"/>
-                <a:ea typeface="Microsoft JhengHei" pitchFamily="34" charset="-120"/>
-                <a:cs typeface="Microsoft JhengHei" pitchFamily="34" charset="-120"/>
-              </a:rPr>
-              <a:t>SmolVLA</a:t>
-            </a:r>
-            <a:endParaRPr lang="zh-TW" altLang="en-US" sz="950" dirty="0"/>
-          </a:p>
-          <a:p>
-            <a:pPr marL="0" indent="0" algn="ctr" eaLnBrk="1" latinLnBrk="0" hangingPunct="1">
-              <a:lnSpc>
-                <a:spcPct val="105000"/>
-              </a:lnSpc>
-              <a:buNone/>
-            </a:pPr>
-            <a:r>
-              <a:rPr lang="zh-TW" altLang="en-US" sz="950" b="1" dirty="0">
-                <a:solidFill>
-                  <a:srgbClr val="1F3A5F"/>
-                </a:solidFill>
-                <a:latin typeface="Microsoft JhengHei" pitchFamily="34" charset="0"/>
-                <a:ea typeface="Microsoft JhengHei" pitchFamily="34" charset="-120"/>
-                <a:cs typeface="Microsoft JhengHei" pitchFamily="34" charset="-120"/>
-              </a:rPr>
-              <a:t>微調</a:t>
-            </a:r>
-            <a:endParaRPr lang="zh-TW" altLang="en-US" sz="950" dirty="0"/>
-          </a:p>
-        </p:txBody>
-      </p:sp>
-      <p:sp>
-        <p:nvSpPr>
-          <p:cNvPr id="37" name="Text 35"/>
-          <p:cNvSpPr txBox="1"/>
-          <p:nvPr/>
-        </p:nvSpPr>
-        <p:spPr>
-          <a:xfrm>
-            <a:off x="5675864" y="3286354"/>
-            <a:ext cx="201168" cy="548640"/>
-          </a:xfrm>
-          <a:prstGeom prst="rect">
-            <a:avLst/>
-          </a:prstGeom>
-          <a:noFill/>
-          <a:ln/>
-        </p:spPr>
-        <p:txBody>
-          <a:bodyPr wrap="square" lIns="0" tIns="0" rIns="0" bIns="0" rtlCol="0" anchor="ctr"/>
-          <a:lstStyle/>
-          <a:p>
-            <a:pPr marL="0" indent="0" algn="ctr" eaLnBrk="1" latinLnBrk="0" hangingPunct="1">
-              <a:buNone/>
-            </a:pPr>
-            <a:r>
-              <a:rPr lang="zh-TW" altLang="en-US" sz="1600" dirty="0">
-                <a:solidFill>
-                  <a:srgbClr val="5F6B7A"/>
-                </a:solidFill>
-                <a:latin typeface="Microsoft JhengHei" pitchFamily="34" charset="0"/>
-                <a:ea typeface="Microsoft JhengHei" pitchFamily="34" charset="-120"/>
-                <a:cs typeface="Microsoft JhengHei" pitchFamily="34" charset="-120"/>
-              </a:rPr>
-              <a:t>›</a:t>
-            </a:r>
-            <a:endParaRPr lang="zh-TW" altLang="en-US" sz="1600" dirty="0"/>
-          </a:p>
-        </p:txBody>
-      </p:sp>
-      <p:sp>
-        <p:nvSpPr>
-          <p:cNvPr id="38" name="Shape 36"/>
-          <p:cNvSpPr/>
-          <p:nvPr/>
-        </p:nvSpPr>
-        <p:spPr>
-          <a:xfrm>
-            <a:off x="5877032" y="3286354"/>
-            <a:ext cx="1130930" cy="548640"/>
+            <a:off x="548640" y="3017520"/>
+            <a:ext cx="365760" cy="256032"/>
           </a:xfrm>
           <a:prstGeom prst="roundRect">
             <a:avLst>
@@ -4665,14 +4093,14 @@
       </p:sp>
       <p:sp>
         <p:nvSpPr>
-          <p:cNvPr id="39" name="Text 37"/>
-          <p:cNvSpPr txBox="1"/>
-          <p:nvPr/>
-        </p:nvSpPr>
-        <p:spPr>
-          <a:xfrm>
-            <a:off x="5877032" y="3286354"/>
-            <a:ext cx="1130930" cy="548640"/>
+          <p:cNvPr id="54" name="S1 badge text"/>
+          <p:cNvSpPr txBox="1"/>
+          <p:nvPr/>
+        </p:nvSpPr>
+        <p:spPr>
+          <a:xfrm>
+            <a:off x="548640" y="3017520"/>
+            <a:ext cx="365760" cy="256032"/>
           </a:xfrm>
           <a:prstGeom prst="rect">
             <a:avLst/>
@@ -4686,7 +4114,7 @@
           <a:p>
             <a:pPr marL="0" indent="0" algn="ctr" eaLnBrk="1" latinLnBrk="0" hangingPunct="1">
               <a:lnSpc>
-                <a:spcPct val="105000"/>
+                <a:spcPct val="100000"/>
               </a:lnSpc>
               <a:buNone/>
             </a:pPr>
@@ -4699,7 +4127,7 @@
                 <a:ea typeface="Microsoft JhengHei" pitchFamily="34" charset="-120"/>
                 <a:cs typeface="Microsoft JhengHei" pitchFamily="34" charset="-120"/>
               </a:rPr>
-              <a:t>真機部署</a:t>
+              <a:t>01</a:t>
             </a:r>
             <a:endParaRPr lang="zh-TW" altLang="en-US" sz="950" dirty="0"/>
           </a:p>
@@ -4707,14 +4135,98 @@
       </p:sp>
       <p:sp>
         <p:nvSpPr>
+          <p:cNvPr id="55" name="S1 title"/>
+          <p:cNvSpPr txBox="1"/>
+          <p:nvPr/>
+        </p:nvSpPr>
+        <p:spPr>
+          <a:xfrm>
+            <a:off x="1024128" y="3017520"/>
+            <a:ext cx="3840480" cy="256032"/>
+          </a:xfrm>
+          <a:prstGeom prst="rect">
+            <a:avLst/>
+          </a:prstGeom>
+          <a:noFill/>
+          <a:ln/>
+        </p:spPr>
+        <p:txBody>
+          <a:bodyPr wrap="square" lIns="0" tIns="0" rIns="0" bIns="0" rtlCol="0" anchor="ctr"/>
+          <a:lstStyle/>
+          <a:p>
+            <a:pPr marL="0" indent="0" eaLnBrk="1" latinLnBrk="0" hangingPunct="1">
+              <a:lnSpc>
+                <a:spcPct val="100000"/>
+              </a:lnSpc>
+              <a:buNone/>
+            </a:pPr>
+            <a:r>
+              <a:rPr lang="zh-TW" altLang="en-US" sz="1250" b="1" dirty="0">
+                <a:solidFill>
+                  <a:srgbClr val="1F3A5F"/>
+                </a:solidFill>
+                <a:latin typeface="Microsoft JhengHei" pitchFamily="34" charset="0"/>
+                <a:ea typeface="Microsoft JhengHei" pitchFamily="34" charset="-120"/>
+                <a:cs typeface="Microsoft JhengHei" pitchFamily="34" charset="-120"/>
+              </a:rPr>
+              <a:t>OpenArm 雙臂模仿學習</a:t>
+            </a:r>
+            <a:endParaRPr lang="zh-TW" altLang="en-US" sz="1250" dirty="0"/>
+          </a:p>
+        </p:txBody>
+      </p:sp>
+      <p:sp>
+        <p:nvSpPr>
+          <p:cNvPr id="56" name="S1 note"/>
+          <p:cNvSpPr txBox="1"/>
+          <p:nvPr/>
+        </p:nvSpPr>
+        <p:spPr>
+          <a:xfrm>
+            <a:off x="4626864" y="3017520"/>
+            <a:ext cx="2377440" cy="256032"/>
+          </a:xfrm>
+          <a:prstGeom prst="rect">
+            <a:avLst/>
+          </a:prstGeom>
+          <a:noFill/>
+          <a:ln/>
+        </p:spPr>
+        <p:txBody>
+          <a:bodyPr wrap="square" lIns="0" tIns="0" rIns="0" bIns="0" rtlCol="0" anchor="ctr"/>
+          <a:lstStyle/>
+          <a:p>
+            <a:pPr marL="0" indent="0" algn="r" eaLnBrk="1" latinLnBrk="0" hangingPunct="1">
+              <a:lnSpc>
+                <a:spcPct val="100000"/>
+              </a:lnSpc>
+              <a:buNone/>
+            </a:pPr>
+            <a:r>
+              <a:rPr lang="zh-TW" altLang="en-US" sz="950" dirty="0">
+                <a:solidFill>
+                  <a:srgbClr val="5F6B7A"/>
+                </a:solidFill>
+                <a:latin typeface="Microsoft JhengHei" pitchFamily="34" charset="0"/>
+                <a:ea typeface="Microsoft JhengHei" pitchFamily="34" charset="-120"/>
+                <a:cs typeface="Microsoft JhengHei" pitchFamily="34" charset="-120"/>
+              </a:rPr>
+              <a:t>雙手交接任務  ·  模擬到真機</a:t>
+            </a:r>
+            <a:endParaRPr lang="zh-TW" altLang="en-US" sz="950" dirty="0"/>
+          </a:p>
+        </p:txBody>
+      </p:sp>
+      <p:sp>
+        <p:nvSpPr>
           <p:cNvPr id="40" name="P2_b"/>
           <p:cNvSpPr txBox="1"/>
           <p:nvPr/>
         </p:nvSpPr>
         <p:spPr>
           <a:xfrm>
-            <a:off x="548640" y="4017874"/>
-            <a:ext cx="6459322" cy="1670609"/>
+            <a:off x="548640" y="3383280"/>
+            <a:ext cx="4261104" cy="1600200"/>
           </a:xfrm>
           <a:prstGeom prst="rect">
             <a:avLst/>
@@ -4736,7 +4248,18 @@
               <a:buNone/>
             </a:pPr>
             <a:r>
-              <a:rPr lang="zh-TW" altLang="en-US" sz="1100" dirty="0">
+              <a:rPr lang="zh-TW" altLang="en-US" sz="1050" b="1" dirty="0">
+                <a:solidFill>
+                  <a:srgbClr val="1F3A5F"/>
+                </a:solidFill>
+                <a:latin typeface="Microsoft JhengHei" pitchFamily="34" charset="0"/>
+                <a:ea typeface="Microsoft JhengHei" pitchFamily="34" charset="-120"/>
+                <a:cs typeface="Microsoft JhengHei" pitchFamily="34" charset="-120"/>
+              </a:rPr>
+              <a:t>做法：</a:t>
+            </a:r>
+            <a:r>
+              <a:rPr lang="zh-TW" altLang="en-US" sz="1050" dirty="0">
                 <a:solidFill>
                   <a:srgbClr val="1F2933"/>
                 </a:solidFill>
@@ -4744,9 +4267,9 @@
                 <a:ea typeface="Microsoft JhengHei" pitchFamily="34" charset="-120"/>
                 <a:cs typeface="Microsoft JhengHei" pitchFamily="34" charset="-120"/>
               </a:rPr>
-              <a:t>一開始擴增出來的資料一直不對，後來參考 Isaac Lab Mimic 官方的雙手交接範例，重新設定子任務的標註斷點，也修好了模擬中手指碰撞失效的狀況。另外接上 VR 做遙操作，在 Isaac Sim 裡錄了約 20 筆人類示範，最後擴增成上千筆訓練資料。</a:t>
-            </a:r>
-            <a:endParaRPr lang="zh-TW" altLang="en-US" sz="1100" dirty="0"/>
+              <a:t>考量時間和成本，我選擇用資料擴增來完成雙手交接任務：接上 VR 在 Isaac Sim 裡遙操作，錄了約 20 筆人類示範，用 Isaac Lab Mimic 擴增成上千筆訓練資料，轉成 LeRobot 資料集微調 SmolVLA，最後在模擬和真機上驗證。</a:t>
+            </a:r>
+            <a:endParaRPr lang="zh-TW" altLang="en-US" sz="1050" dirty="0"/>
           </a:p>
           <a:p>
             <a:pPr marL="0" indent="0" eaLnBrk="1" latinLnBrk="0" hangingPunct="1">
@@ -4759,7 +4282,7 @@
               <a:buNone/>
             </a:pPr>
             <a:r>
-              <a:rPr lang="zh-TW" altLang="en-US" sz="1100" b="1" dirty="0">
+              <a:rPr lang="zh-TW" altLang="en-US" sz="1050" b="1" dirty="0">
                 <a:solidFill>
                   <a:srgbClr val="1F3A5F"/>
                 </a:solidFill>
@@ -4767,10 +4290,10 @@
                 <a:ea typeface="Microsoft JhengHei" pitchFamily="34" charset="-120"/>
                 <a:cs typeface="Microsoft JhengHei" pitchFamily="34" charset="-120"/>
               </a:rPr>
-              <a:t>二、UMI 夾爪設計：</a:t>
-            </a:r>
-            <a:r>
-              <a:rPr lang="zh-TW" altLang="en-US" sz="1100" dirty="0">
+              <a:t>除錯：</a:t>
+            </a:r>
+            <a:r>
+              <a:rPr lang="zh-TW" altLang="en-US" sz="1050" dirty="0">
                 <a:solidFill>
                   <a:srgbClr val="1F2933"/>
                 </a:solidFill>
@@ -4778,32 +4301,9 @@
                 <a:ea typeface="Microsoft JhengHei" pitchFamily="34" charset="-120"/>
                 <a:cs typeface="Microsoft JhengHei" pitchFamily="34" charset="-120"/>
               </a:rPr>
-              <a:t>同一時間，我也幫一個還沒公開的專案設計夾爪。參考網路上幾種對稱開合的機構後畫出自己的版本，用 3D 列印反覆測試修改，最後裝到該專案雙足機器人的手臂末端。之後接手的同學就能用它，照 UMI 開源夾爪的做法訓練模型。</a:t>
-            </a:r>
-            <a:endParaRPr lang="zh-TW" altLang="en-US" sz="1100" dirty="0"/>
-          </a:p>
-          <a:p>
-            <a:pPr marL="0" indent="0" eaLnBrk="1" latinLnBrk="0" hangingPunct="1">
-              <a:lnSpc>
-                <a:spcPct val="130000"/>
-              </a:lnSpc>
-              <a:spcAft>
-                <a:spcPts val="500"/>
-              </a:spcAft>
-              <a:buNone/>
-            </a:pPr>
-            <a:r>
-              <a:rPr lang="zh-TW" altLang="en-US" sz="1100" dirty="0">
-                <a:solidFill>
-                  <a:srgbClr val="1F2933"/>
-                </a:solidFill>
-                <a:latin typeface="Microsoft JhengHei" pitchFamily="34" charset="0"/>
-                <a:ea typeface="Microsoft JhengHei" pitchFamily="34" charset="-120"/>
-                <a:cs typeface="Microsoft JhengHei" pitchFamily="34" charset="-120"/>
-              </a:rPr>
-              <a:t>這兩個月實際從模擬做到真機（sim-to-real），也讓我在機器人學習這個方向上鑽得更深。</a:t>
-            </a:r>
-            <a:endParaRPr lang="zh-TW" altLang="en-US" sz="1100" dirty="0"/>
+              <a:t>一開始擴增出來的資料一直不對，後來參考 Isaac Lab Mimic 官方的雙手交接範例，重新設定子任務的標註斷點，也修好了模擬中手指碰撞失效的狀況。</a:t>
+            </a:r>
+            <a:endParaRPr lang="zh-TW" altLang="en-US" sz="1050" dirty="0"/>
           </a:p>
         </p:txBody>
       </p:sp>
@@ -4823,38 +4323,14 @@
         </p:blipFill>
         <p:spPr>
           <a:xfrm>
-            <a:off x="483059" y="7849456"/>
-            <a:ext cx="2900266" cy="2289410"/>
+            <a:off x="5084064" y="3383280"/>
+            <a:ext cx="1920240" cy="1515798"/>
           </a:xfrm>
           <a:prstGeom prst="rect">
             <a:avLst/>
           </a:prstGeom>
         </p:spPr>
       </p:pic>
-      <p:pic>
-        <p:nvPicPr>
-          <p:cNvPr id="42" name="Image 1" descr="gripper"/>
-          <p:cNvPicPr>
-            <a:picLocks noChangeAspect="1"/>
-          </p:cNvPicPr>
-          <p:nvPr/>
-        </p:nvPicPr>
-        <p:blipFill>
-          <a:blip r:embed="rId4"/>
-          <a:stretch>
-            <a:fillRect/>
-          </a:stretch>
-        </p:blipFill>
-        <p:spPr>
-          <a:xfrm>
-            <a:off x="4153863" y="7972746"/>
-            <a:ext cx="2252894" cy="2166120"/>
-          </a:xfrm>
-          <a:prstGeom prst="rect">
-            <a:avLst/>
-          </a:prstGeom>
-        </p:spPr>
-      </p:pic>
       <p:sp>
         <p:nvSpPr>
           <p:cNvPr id="43" name="Text 39"/>
@@ -4863,8 +4339,8 @@
         </p:nvSpPr>
         <p:spPr>
           <a:xfrm>
-            <a:off x="483059" y="10212019"/>
-            <a:ext cx="3396484" cy="237744"/>
+            <a:off x="5084064" y="4935654"/>
+            <a:ext cx="1920240" cy="201168"/>
           </a:xfrm>
           <a:prstGeom prst="rect">
             <a:avLst/>
@@ -4889,45 +4365,6 @@
                 <a:cs typeface="Microsoft JhengHei" pitchFamily="34" charset="-120"/>
               </a:rPr>
               <a:t>Episode replay in Isaac Sim</a:t>
-            </a:r>
-            <a:endParaRPr lang="zh-TW" altLang="en-US" sz="950" dirty="0"/>
-          </a:p>
-        </p:txBody>
-      </p:sp>
-      <p:sp>
-        <p:nvSpPr>
-          <p:cNvPr id="44" name="Text 40"/>
-          <p:cNvSpPr txBox="1"/>
-          <p:nvPr/>
-        </p:nvSpPr>
-        <p:spPr>
-          <a:xfrm>
-            <a:off x="4153863" y="10212019"/>
-            <a:ext cx="2788518" cy="237744"/>
-          </a:xfrm>
-          <a:prstGeom prst="rect">
-            <a:avLst/>
-          </a:prstGeom>
-          <a:noFill/>
-          <a:ln/>
-        </p:spPr>
-        <p:txBody>
-          <a:bodyPr wrap="square" lIns="0" tIns="0" rIns="0" bIns="0" rtlCol="0" anchor="t"/>
-          <a:lstStyle/>
-          <a:p>
-            <a:pPr marL="0" indent="0" algn="ctr" eaLnBrk="1" latinLnBrk="0" hangingPunct="1">
-              <a:buNone/>
-            </a:pPr>
-            <a:r>
-              <a:rPr lang="zh-TW" altLang="en-US" sz="950" dirty="0">
-                <a:solidFill>
-                  <a:srgbClr val="5F6B7A"/>
-                </a:solidFill>
-                <a:latin typeface="Microsoft JhengHei" pitchFamily="34" charset="0"/>
-                <a:ea typeface="Microsoft JhengHei" pitchFamily="34" charset="-120"/>
-                <a:cs typeface="Microsoft JhengHei" pitchFamily="34" charset="-120"/>
-              </a:rPr>
-              <a:t>為開源專案設計的夾爪（UMI gripper）</a:t>
             </a:r>
             <a:endParaRPr lang="zh-TW" altLang="en-US" sz="950" dirty="0"/>
           </a:p>
@@ -4956,8 +4393,8 @@
         </p:blipFill>
         <p:spPr>
           <a:xfrm>
-            <a:off x="1047965" y="5675680"/>
-            <a:ext cx="5045598" cy="2010930"/>
+            <a:off x="1353312" y="5340096"/>
+            <a:ext cx="4846320" cy="1931507"/>
           </a:xfrm>
           <a:prstGeom prst="rect">
             <a:avLst/>
@@ -4966,49 +4403,433 @@
       </p:pic>
       <p:sp>
         <p:nvSpPr>
-          <p:cNvPr id="52" name="文字方塊 51">
-            <a:extLst>
-              <a:ext uri="{FF2B5EF4-FFF2-40B4-BE49-F238E27FC236}">
-                <a16:creationId xmlns:a16="http://schemas.microsoft.com/office/drawing/2014/main" id="{86DA19C1-EE3B-E3E8-C18E-CEFAA9797CBD}"/>
-              </a:ext>
-            </a:extLst>
-          </p:cNvPr>
-          <p:cNvSpPr txBox="1"/>
-          <p:nvPr/>
-        </p:nvSpPr>
-        <p:spPr>
-          <a:xfrm>
-            <a:off x="2192939" y="7606936"/>
-            <a:ext cx="4093561" cy="276999"/>
-          </a:xfrm>
-          <a:prstGeom prst="rect">
-            <a:avLst/>
-          </a:prstGeom>
-          <a:noFill/>
-        </p:spPr>
-        <p:txBody>
-          <a:bodyPr wrap="square">
-            <a:spAutoFit/>
-          </a:bodyPr>
-          <a:lstStyle/>
-          <a:p>
-            <a:r>
-              <a:rPr lang="en-US" altLang="zh-TW" sz="1200" dirty="0"/>
-              <a:t>Demo</a:t>
-            </a:r>
-            <a:r>
-              <a:rPr lang="en-US" altLang="zh-TW" sz="1200" dirty="0">
+          <p:cNvPr id="57" name="Pipeline caption"/>
+          <p:cNvSpPr txBox="1"/>
+          <p:nvPr/>
+        </p:nvSpPr>
+        <p:spPr>
+          <a:xfrm>
+            <a:off x="548640" y="7317323"/>
+            <a:ext cx="6455664" cy="201168"/>
+          </a:xfrm>
+          <a:prstGeom prst="rect">
+            <a:avLst/>
+          </a:prstGeom>
+          <a:noFill/>
+          <a:ln/>
+        </p:spPr>
+        <p:txBody>
+          <a:bodyPr wrap="square" lIns="0" tIns="0" rIns="0" bIns="0" rtlCol="0" anchor="t"/>
+          <a:lstStyle/>
+          <a:p>
+            <a:pPr marL="0" indent="0" algn="ctr" eaLnBrk="1" latinLnBrk="0" hangingPunct="1">
+              <a:lnSpc>
+                <a:spcPct val="100000"/>
+              </a:lnSpc>
+              <a:buNone/>
+            </a:pPr>
+            <a:r>
+              <a:rPr lang="zh-TW" altLang="en-US" sz="900" dirty="0">
+                <a:solidFill>
+                  <a:srgbClr val="5F6B7A"/>
+                </a:solidFill>
+                <a:latin typeface="Microsoft JhengHei" pitchFamily="34" charset="0"/>
+                <a:ea typeface="Microsoft JhengHei" pitchFamily="34" charset="-120"/>
+                <a:cs typeface="Microsoft JhengHei" pitchFamily="34" charset="-120"/>
+              </a:rPr>
+              <a:t>遙操作、資料擴增到模擬與真機評估的完整流程     </a:t>
+            </a:r>
+            <a:r>
+              <a:rPr lang="zh-TW" altLang="en-US" sz="900" b="1" u="sng" dirty="0">
+                <a:solidFill>
+                  <a:srgbClr val="1F3A5F"/>
+                </a:solidFill>
+                <a:latin typeface="Microsoft JhengHei" pitchFamily="34" charset="0"/>
+                <a:ea typeface="Microsoft JhengHei" pitchFamily="34" charset="-120"/>
+                <a:cs typeface="Microsoft JhengHei" pitchFamily="34" charset="-120"/>
                 <a:hlinkClick r:id="rId6"/>
               </a:rPr>
-              <a:t>:</a:t>
-            </a:r>
-            <a:r>
-              <a:rPr lang="zh-TW" altLang="en-US" sz="1200" dirty="0">
-                <a:hlinkClick r:id="rId6"/>
-              </a:rPr>
-              <a:t>https://youtu.be/BDO_n6OTzGI</a:t>
-            </a:r>
-            <a:endParaRPr lang="zh-TW" altLang="en-US" sz="1200" dirty="0"/>
+              <a:t>▶ Demo 影片：youtu.be/BDO_n6OTzGI</a:t>
+            </a:r>
+            <a:endParaRPr lang="zh-TW" altLang="en-US" sz="900" dirty="0"/>
+          </a:p>
+        </p:txBody>
+      </p:sp>
+      <p:sp>
+        <p:nvSpPr>
+          <p:cNvPr id="58" name="S2 badge"/>
+          <p:cNvSpPr/>
+          <p:nvPr/>
+        </p:nvSpPr>
+        <p:spPr>
+          <a:xfrm>
+            <a:off x="548640" y="7662672"/>
+            <a:ext cx="365760" cy="256032"/>
+          </a:xfrm>
+          <a:prstGeom prst="roundRect">
+            <a:avLst>
+              <a:gd name="adj" fmla="val 11667"/>
+            </a:avLst>
+          </a:prstGeom>
+          <a:solidFill>
+            <a:srgbClr val="1F3A5F"/>
+          </a:solidFill>
+          <a:ln w="9525">
+            <a:solidFill>
+              <a:srgbClr val="1F3A5F"/>
+            </a:solidFill>
+            <a:prstDash val="solid"/>
+          </a:ln>
+        </p:spPr>
+        <p:txBody>
+          <a:bodyPr/>
+          <a:lstStyle/>
+          <a:p>
+            <a:endParaRPr lang="zh-TW" altLang="en-US"/>
+          </a:p>
+        </p:txBody>
+      </p:sp>
+      <p:sp>
+        <p:nvSpPr>
+          <p:cNvPr id="59" name="S2 badge text"/>
+          <p:cNvSpPr txBox="1"/>
+          <p:nvPr/>
+        </p:nvSpPr>
+        <p:spPr>
+          <a:xfrm>
+            <a:off x="548640" y="7662672"/>
+            <a:ext cx="365760" cy="256032"/>
+          </a:xfrm>
+          <a:prstGeom prst="rect">
+            <a:avLst/>
+          </a:prstGeom>
+          <a:noFill/>
+          <a:ln/>
+        </p:spPr>
+        <p:txBody>
+          <a:bodyPr wrap="square" lIns="0" tIns="0" rIns="0" bIns="0" rtlCol="0" anchor="ctr"/>
+          <a:lstStyle/>
+          <a:p>
+            <a:pPr marL="0" indent="0" algn="ctr" eaLnBrk="1" latinLnBrk="0" hangingPunct="1">
+              <a:lnSpc>
+                <a:spcPct val="100000"/>
+              </a:lnSpc>
+              <a:buNone/>
+            </a:pPr>
+            <a:r>
+              <a:rPr lang="zh-TW" altLang="en-US" sz="950" b="1" dirty="0">
+                <a:solidFill>
+                  <a:srgbClr val="FFFFFF"/>
+                </a:solidFill>
+                <a:latin typeface="Microsoft JhengHei" pitchFamily="34" charset="0"/>
+                <a:ea typeface="Microsoft JhengHei" pitchFamily="34" charset="-120"/>
+                <a:cs typeface="Microsoft JhengHei" pitchFamily="34" charset="-120"/>
+              </a:rPr>
+              <a:t>02</a:t>
+            </a:r>
+            <a:endParaRPr lang="zh-TW" altLang="en-US" sz="950" dirty="0"/>
+          </a:p>
+        </p:txBody>
+      </p:sp>
+      <p:sp>
+        <p:nvSpPr>
+          <p:cNvPr id="60" name="S2 title"/>
+          <p:cNvSpPr txBox="1"/>
+          <p:nvPr/>
+        </p:nvSpPr>
+        <p:spPr>
+          <a:xfrm>
+            <a:off x="1024128" y="7662672"/>
+            <a:ext cx="3840480" cy="256032"/>
+          </a:xfrm>
+          <a:prstGeom prst="rect">
+            <a:avLst/>
+          </a:prstGeom>
+          <a:noFill/>
+          <a:ln/>
+        </p:spPr>
+        <p:txBody>
+          <a:bodyPr wrap="square" lIns="0" tIns="0" rIns="0" bIns="0" rtlCol="0" anchor="ctr"/>
+          <a:lstStyle/>
+          <a:p>
+            <a:pPr marL="0" indent="0" eaLnBrk="1" latinLnBrk="0" hangingPunct="1">
+              <a:lnSpc>
+                <a:spcPct val="100000"/>
+              </a:lnSpc>
+              <a:buNone/>
+            </a:pPr>
+            <a:r>
+              <a:rPr lang="zh-TW" altLang="en-US" sz="1250" b="1" dirty="0">
+                <a:solidFill>
+                  <a:srgbClr val="1F3A5F"/>
+                </a:solidFill>
+                <a:latin typeface="Microsoft JhengHei" pitchFamily="34" charset="0"/>
+                <a:ea typeface="Microsoft JhengHei" pitchFamily="34" charset="-120"/>
+                <a:cs typeface="Microsoft JhengHei" pitchFamily="34" charset="-120"/>
+              </a:rPr>
+              <a:t>UMI 夾爪設計</a:t>
+            </a:r>
+            <a:endParaRPr lang="zh-TW" altLang="en-US" sz="1250" dirty="0"/>
+          </a:p>
+        </p:txBody>
+      </p:sp>
+      <p:sp>
+        <p:nvSpPr>
+          <p:cNvPr id="61" name="S2 note"/>
+          <p:cNvSpPr txBox="1"/>
+          <p:nvPr/>
+        </p:nvSpPr>
+        <p:spPr>
+          <a:xfrm>
+            <a:off x="4626864" y="7662672"/>
+            <a:ext cx="2377440" cy="256032"/>
+          </a:xfrm>
+          <a:prstGeom prst="rect">
+            <a:avLst/>
+          </a:prstGeom>
+          <a:noFill/>
+          <a:ln/>
+        </p:spPr>
+        <p:txBody>
+          <a:bodyPr wrap="square" lIns="0" tIns="0" rIns="0" bIns="0" rtlCol="0" anchor="ctr"/>
+          <a:lstStyle/>
+          <a:p>
+            <a:pPr marL="0" indent="0" algn="r" eaLnBrk="1" latinLnBrk="0" hangingPunct="1">
+              <a:lnSpc>
+                <a:spcPct val="100000"/>
+              </a:lnSpc>
+              <a:buNone/>
+            </a:pPr>
+            <a:r>
+              <a:rPr lang="zh-TW" altLang="en-US" sz="950" dirty="0">
+                <a:solidFill>
+                  <a:srgbClr val="5F6B7A"/>
+                </a:solidFill>
+                <a:latin typeface="Microsoft JhengHei" pitchFamily="34" charset="0"/>
+                <a:ea typeface="Microsoft JhengHei" pitchFamily="34" charset="-120"/>
+                <a:cs typeface="Microsoft JhengHei" pitchFamily="34" charset="-120"/>
+              </a:rPr>
+              <a:t>機構設計  ·  3D 列印</a:t>
+            </a:r>
+            <a:endParaRPr lang="zh-TW" altLang="en-US" sz="950" dirty="0"/>
+          </a:p>
+        </p:txBody>
+      </p:sp>
+      <p:pic>
+        <p:nvPicPr>
+          <p:cNvPr id="42" name="Image 1" descr="gripper"/>
+          <p:cNvPicPr>
+            <a:picLocks noChangeAspect="1"/>
+          </p:cNvPicPr>
+          <p:nvPr/>
+        </p:nvPicPr>
+        <p:blipFill>
+          <a:blip r:embed="rId4"/>
+          <a:stretch>
+            <a:fillRect/>
+          </a:stretch>
+        </p:blipFill>
+        <p:spPr>
+          <a:xfrm>
+            <a:off x="548640" y="8028432"/>
+            <a:ext cx="1920240" cy="1846279"/>
+          </a:xfrm>
+          <a:prstGeom prst="rect">
+            <a:avLst/>
+          </a:prstGeom>
+        </p:spPr>
+      </p:pic>
+      <p:sp>
+        <p:nvSpPr>
+          <p:cNvPr id="44" name="Text 40"/>
+          <p:cNvSpPr txBox="1"/>
+          <p:nvPr/>
+        </p:nvSpPr>
+        <p:spPr>
+          <a:xfrm>
+            <a:off x="548640" y="9911287"/>
+            <a:ext cx="1920240" cy="201168"/>
+          </a:xfrm>
+          <a:prstGeom prst="rect">
+            <a:avLst/>
+          </a:prstGeom>
+          <a:noFill/>
+          <a:ln/>
+        </p:spPr>
+        <p:txBody>
+          <a:bodyPr wrap="square" lIns="0" tIns="0" rIns="0" bIns="0" rtlCol="0" anchor="t"/>
+          <a:lstStyle/>
+          <a:p>
+            <a:pPr marL="0" indent="0" algn="ctr" eaLnBrk="1" latinLnBrk="0" hangingPunct="1">
+              <a:buNone/>
+            </a:pPr>
+            <a:r>
+              <a:rPr lang="zh-TW" altLang="en-US" sz="950" dirty="0">
+                <a:solidFill>
+                  <a:srgbClr val="5F6B7A"/>
+                </a:solidFill>
+                <a:latin typeface="Microsoft JhengHei" pitchFamily="34" charset="0"/>
+                <a:ea typeface="Microsoft JhengHei" pitchFamily="34" charset="-120"/>
+                <a:cs typeface="Microsoft JhengHei" pitchFamily="34" charset="-120"/>
+              </a:rPr>
+              <a:t>UMI 夾爪實機（3D 列印）</a:t>
+            </a:r>
+            <a:endParaRPr lang="zh-TW" altLang="en-US" sz="950" dirty="0"/>
+          </a:p>
+        </p:txBody>
+      </p:sp>
+      <p:sp>
+        <p:nvSpPr>
+          <p:cNvPr id="62" name="P2_c"/>
+          <p:cNvSpPr txBox="1"/>
+          <p:nvPr/>
+        </p:nvSpPr>
+        <p:spPr>
+          <a:xfrm>
+            <a:off x="2743200" y="8028432"/>
+            <a:ext cx="4261104" cy="960120"/>
+          </a:xfrm>
+          <a:prstGeom prst="rect">
+            <a:avLst/>
+          </a:prstGeom>
+          <a:noFill/>
+          <a:ln/>
+        </p:spPr>
+        <p:txBody>
+          <a:bodyPr wrap="square" lIns="0" tIns="0" rIns="0" bIns="0" rtlCol="0" anchor="t"/>
+          <a:lstStyle/>
+          <a:p>
+            <a:pPr marL="0" indent="0" eaLnBrk="1" latinLnBrk="0" hangingPunct="1">
+              <a:lnSpc>
+                <a:spcPct val="130000"/>
+              </a:lnSpc>
+              <a:spcAft>
+                <a:spcPts val="500"/>
+              </a:spcAft>
+              <a:buNone/>
+            </a:pPr>
+            <a:r>
+              <a:rPr lang="zh-TW" altLang="en-US" sz="1050" dirty="0">
+                <a:solidFill>
+                  <a:srgbClr val="1F2933"/>
+                </a:solidFill>
+                <a:latin typeface="Microsoft JhengHei" pitchFamily="34" charset="0"/>
+                <a:ea typeface="Microsoft JhengHei" pitchFamily="34" charset="-120"/>
+                <a:cs typeface="Microsoft JhengHei" pitchFamily="34" charset="-120"/>
+              </a:rPr>
+              <a:t>同一時間，我也幫一個還沒公開的專案設計夾爪。參考網路上幾種對稱開合的機構後畫出自己的版本，用 3D 列印反覆測試修改，最後裝到該專案雙足機器人的手臂末端。</a:t>
+            </a:r>
+            <a:endParaRPr lang="zh-TW" altLang="en-US" sz="1050" dirty="0"/>
+          </a:p>
+          <a:p>
+            <a:pPr marL="0" indent="0" eaLnBrk="1" latinLnBrk="0" hangingPunct="1">
+              <a:lnSpc>
+                <a:spcPct val="130000"/>
+              </a:lnSpc>
+              <a:spcAft>
+                <a:spcPts val="500"/>
+              </a:spcAft>
+              <a:buNone/>
+            </a:pPr>
+            <a:r>
+              <a:rPr lang="zh-TW" altLang="en-US" sz="1050" dirty="0">
+                <a:solidFill>
+                  <a:srgbClr val="1F2933"/>
+                </a:solidFill>
+                <a:latin typeface="Microsoft JhengHei" pitchFamily="34" charset="0"/>
+                <a:ea typeface="Microsoft JhengHei" pitchFamily="34" charset="-120"/>
+                <a:cs typeface="Microsoft JhengHei" pitchFamily="34" charset="-120"/>
+              </a:rPr>
+              <a:t>之後接手的同學就能用它，照 UMI 開源夾爪的做法訓練模型。</a:t>
+            </a:r>
+            <a:endParaRPr lang="zh-TW" altLang="en-US" sz="1050" dirty="0"/>
+          </a:p>
+        </p:txBody>
+      </p:sp>
+      <p:sp>
+        <p:nvSpPr>
+          <p:cNvPr id="63" name="Takeaway box"/>
+          <p:cNvSpPr/>
+          <p:nvPr/>
+        </p:nvSpPr>
+        <p:spPr>
+          <a:xfrm>
+            <a:off x="2743200" y="9198055"/>
+            <a:ext cx="4261104" cy="676656"/>
+          </a:xfrm>
+          <a:prstGeom prst="roundRect">
+            <a:avLst>
+              <a:gd name="adj" fmla="val 11667"/>
+            </a:avLst>
+          </a:prstGeom>
+          <a:solidFill>
+            <a:srgbClr val="EEF2F7"/>
+          </a:solidFill>
+          <a:ln w="9525">
+            <a:solidFill>
+              <a:srgbClr val="C9D1DC"/>
+            </a:solidFill>
+            <a:prstDash val="solid"/>
+          </a:ln>
+        </p:spPr>
+        <p:txBody>
+          <a:bodyPr/>
+          <a:lstStyle/>
+          <a:p>
+            <a:endParaRPr lang="zh-TW" altLang="en-US"/>
+          </a:p>
+        </p:txBody>
+      </p:sp>
+      <p:sp>
+        <p:nvSpPr>
+          <p:cNvPr id="64" name="Takeaway text"/>
+          <p:cNvSpPr txBox="1"/>
+          <p:nvPr/>
+        </p:nvSpPr>
+        <p:spPr>
+          <a:xfrm>
+            <a:off x="2907792" y="9198055"/>
+            <a:ext cx="3931920" cy="676656"/>
+          </a:xfrm>
+          <a:prstGeom prst="rect">
+            <a:avLst/>
+          </a:prstGeom>
+          <a:noFill/>
+          <a:ln/>
+        </p:spPr>
+        <p:txBody>
+          <a:bodyPr wrap="square" lIns="0" tIns="0" rIns="0" bIns="0" rtlCol="0" anchor="ctr"/>
+          <a:lstStyle/>
+          <a:p>
+            <a:pPr marL="0" indent="0" eaLnBrk="1" latinLnBrk="0" hangingPunct="1">
+              <a:lnSpc>
+                <a:spcPct val="130000"/>
+              </a:lnSpc>
+              <a:buNone/>
+            </a:pPr>
+            <a:r>
+              <a:rPr lang="zh-TW" altLang="en-US" sz="1050" b="1" dirty="0">
+                <a:solidFill>
+                  <a:srgbClr val="1F3A5F"/>
+                </a:solidFill>
+                <a:latin typeface="Microsoft JhengHei" pitchFamily="34" charset="0"/>
+                <a:ea typeface="Microsoft JhengHei" pitchFamily="34" charset="-120"/>
+                <a:cs typeface="Microsoft JhengHei" pitchFamily="34" charset="-120"/>
+              </a:rPr>
+              <a:t>收穫：</a:t>
+            </a:r>
+            <a:r>
+              <a:rPr lang="zh-TW" altLang="en-US" sz="1050" dirty="0">
+                <a:solidFill>
+                  <a:srgbClr val="1F2933"/>
+                </a:solidFill>
+                <a:latin typeface="Microsoft JhengHei" pitchFamily="34" charset="0"/>
+                <a:ea typeface="Microsoft JhengHei" pitchFamily="34" charset="-120"/>
+                <a:cs typeface="Microsoft JhengHei" pitchFamily="34" charset="-120"/>
+              </a:rPr>
+              <a:t>這兩個月實際從模擬做到真機（sim-to-real），也讓我在機器人學習這個方向上鑽得更深。</a:t>
+            </a:r>
+            <a:endParaRPr lang="zh-TW" altLang="en-US" sz="1050" dirty="0"/>
           </a:p>
         </p:txBody>
       </p:sp>
@@ -5022,15 +4843,7 @@
 
 <file path=ppt/slides/slide3.xml><?xml version="1.0" encoding="utf-8"?>
 <p:sld xmlns:a="http://schemas.openxmlformats.org/drawingml/2006/main" xmlns:r="http://schemas.openxmlformats.org/officeDocument/2006/relationships" xmlns:p="http://schemas.openxmlformats.org/presentationml/2006/main">
-  <p:cSld name="Slide 3">
-    <p:bg>
-      <p:bgPr>
-        <a:solidFill>
-          <a:srgbClr val="FFFFFF"/>
-        </a:solidFill>
-        <a:effectLst/>
-      </p:bgPr>
-    </p:bg>
+  <p:cSld>
     <p:spTree>
       <p:nvGrpSpPr>
         <p:cNvPr id="1" name=""/>
@@ -5541,14 +5354,14 @@
       </p:sp>
       <p:sp>
         <p:nvSpPr>
-          <p:cNvPr id="15" name="Shape 13"/>
+          <p:cNvPr id="17" name="Shape 15"/>
           <p:cNvSpPr/>
           <p:nvPr/>
         </p:nvSpPr>
         <p:spPr>
           <a:xfrm>
             <a:off x="2859329" y="1956816"/>
-            <a:ext cx="790956" cy="246888"/>
+            <a:ext cx="676656" cy="246888"/>
           </a:xfrm>
           <a:prstGeom prst="roundRect">
             <a:avLst>
@@ -5575,14 +5388,14 @@
       </p:sp>
       <p:sp>
         <p:nvSpPr>
-          <p:cNvPr id="16" name="Text 14"/>
+          <p:cNvPr id="18" name="Text 16"/>
           <p:cNvSpPr txBox="1"/>
           <p:nvPr/>
         </p:nvSpPr>
         <p:spPr>
           <a:xfrm>
             <a:off x="2859329" y="1956816"/>
-            <a:ext cx="790956" cy="246888"/>
+            <a:ext cx="676656" cy="246888"/>
           </a:xfrm>
           <a:prstGeom prst="rect">
             <a:avLst/>
@@ -5606,7 +5419,7 @@
                 <a:ea typeface="Microsoft JhengHei" pitchFamily="34" charset="-120"/>
                 <a:cs typeface="Microsoft JhengHei" pitchFamily="34" charset="-120"/>
               </a:rPr>
-              <a:t>鋁擠型車體</a:t>
+              <a:t>電路佈局</a:t>
             </a:r>
             <a:endParaRPr lang="zh-TW" altLang="en-US" sz="900" dirty="0"/>
           </a:p>
@@ -5614,13 +5427,13 @@
       </p:sp>
       <p:sp>
         <p:nvSpPr>
-          <p:cNvPr id="17" name="Shape 15"/>
+          <p:cNvPr id="19" name="Shape 17"/>
           <p:cNvSpPr/>
           <p:nvPr/>
         </p:nvSpPr>
         <p:spPr>
           <a:xfrm>
-            <a:off x="3718865" y="1956816"/>
+            <a:off x="3604565" y="1956816"/>
             <a:ext cx="676656" cy="246888"/>
           </a:xfrm>
           <a:prstGeom prst="roundRect">
@@ -5648,13 +5461,13 @@
       </p:sp>
       <p:sp>
         <p:nvSpPr>
-          <p:cNvPr id="18" name="Text 16"/>
-          <p:cNvSpPr txBox="1"/>
-          <p:nvPr/>
-        </p:nvSpPr>
-        <p:spPr>
-          <a:xfrm>
-            <a:off x="3718865" y="1956816"/>
+          <p:cNvPr id="20" name="Text 18"/>
+          <p:cNvSpPr txBox="1"/>
+          <p:nvPr/>
+        </p:nvSpPr>
+        <p:spPr>
+          <a:xfrm>
+            <a:off x="3604565" y="1956816"/>
             <a:ext cx="676656" cy="246888"/>
           </a:xfrm>
           <a:prstGeom prst="rect">
@@ -5679,7 +5492,7 @@
                 <a:ea typeface="Microsoft JhengHei" pitchFamily="34" charset="-120"/>
                 <a:cs typeface="Microsoft JhengHei" pitchFamily="34" charset="-120"/>
               </a:rPr>
-              <a:t>電路佈局</a:t>
+              <a:t>快速原型</a:t>
             </a:r>
             <a:endParaRPr lang="zh-TW" altLang="en-US" sz="900" dirty="0"/>
           </a:p>
@@ -5687,13 +5500,13 @@
       </p:sp>
       <p:sp>
         <p:nvSpPr>
-          <p:cNvPr id="19" name="Shape 17"/>
+          <p:cNvPr id="30" name="Tag box 2"/>
           <p:cNvSpPr/>
           <p:nvPr/>
         </p:nvSpPr>
         <p:spPr>
           <a:xfrm>
-            <a:off x="4464101" y="1956816"/>
+            <a:off x="4343766" y="1956816"/>
             <a:ext cx="676656" cy="246888"/>
           </a:xfrm>
           <a:prstGeom prst="roundRect">
@@ -5721,13 +5534,13 @@
       </p:sp>
       <p:sp>
         <p:nvSpPr>
-          <p:cNvPr id="20" name="Text 18"/>
-          <p:cNvSpPr txBox="1"/>
-          <p:nvPr/>
-        </p:nvSpPr>
-        <p:spPr>
-          <a:xfrm>
-            <a:off x="4464101" y="1956816"/>
+          <p:cNvPr id="31" name="Tag text 2"/>
+          <p:cNvSpPr txBox="1"/>
+          <p:nvPr/>
+        </p:nvSpPr>
+        <p:spPr>
+          <a:xfrm>
+            <a:off x="4343766" y="1956816"/>
             <a:ext cx="676656" cy="246888"/>
           </a:xfrm>
           <a:prstGeom prst="rect">
@@ -5752,153 +5565,7 @@
                 <a:ea typeface="Microsoft JhengHei" pitchFamily="34" charset="-120"/>
                 <a:cs typeface="Microsoft JhengHei" pitchFamily="34" charset="-120"/>
               </a:rPr>
-              <a:t>快速原型</a:t>
-            </a:r>
-            <a:endParaRPr lang="zh-TW" altLang="en-US" sz="900" dirty="0"/>
-          </a:p>
-        </p:txBody>
-      </p:sp>
-      <p:sp>
-        <p:nvSpPr>
-          <p:cNvPr id="28" name="Tag box 1"/>
-          <p:cNvSpPr/>
-          <p:nvPr/>
-        </p:nvSpPr>
-        <p:spPr>
-          <a:xfrm>
-            <a:off x="5209337" y="1956816"/>
-            <a:ext cx="676656" cy="246888"/>
-          </a:xfrm>
-          <a:prstGeom prst="roundRect">
-            <a:avLst>
-              <a:gd name="adj" fmla="val 22222"/>
-            </a:avLst>
-          </a:prstGeom>
-          <a:solidFill>
-            <a:srgbClr val="E3EAF3"/>
-          </a:solidFill>
-          <a:ln w="12700">
-            <a:solidFill>
-              <a:srgbClr val="E3EAF3"/>
-            </a:solidFill>
-            <a:prstDash val="solid"/>
-          </a:ln>
-        </p:spPr>
-        <p:txBody>
-          <a:bodyPr/>
-          <a:lstStyle/>
-          <a:p>
-            <a:endParaRPr lang="zh-TW" altLang="en-US"/>
-          </a:p>
-        </p:txBody>
-      </p:sp>
-      <p:sp>
-        <p:nvSpPr>
-          <p:cNvPr id="29" name="Tag text 1"/>
-          <p:cNvSpPr txBox="1"/>
-          <p:nvPr/>
-        </p:nvSpPr>
-        <p:spPr>
-          <a:xfrm>
-            <a:off x="5209337" y="1956816"/>
-            <a:ext cx="676656" cy="246888"/>
-          </a:xfrm>
-          <a:prstGeom prst="rect">
-            <a:avLst/>
-          </a:prstGeom>
-          <a:noFill/>
-          <a:ln/>
-        </p:spPr>
-        <p:txBody>
-          <a:bodyPr wrap="square" lIns="0" tIns="0" rIns="0" bIns="0" rtlCol="0" anchor="ctr"/>
-          <a:lstStyle/>
-          <a:p>
-            <a:pPr marL="0" indent="0" algn="ctr" eaLnBrk="1" latinLnBrk="0" hangingPunct="1">
-              <a:buNone/>
-            </a:pPr>
-            <a:r>
-              <a:rPr lang="zh-TW" altLang="en-US" sz="900" dirty="0">
-                <a:solidFill>
-                  <a:srgbClr val="1F3A5F"/>
-                </a:solidFill>
-                <a:latin typeface="Microsoft JhengHei" pitchFamily="34" charset="0"/>
-                <a:ea typeface="Microsoft JhengHei" pitchFamily="34" charset="-120"/>
-                <a:cs typeface="Microsoft JhengHei" pitchFamily="34" charset="-120"/>
-              </a:rPr>
-              <a:t>失效分析</a:t>
-            </a:r>
-            <a:endParaRPr lang="zh-TW" altLang="en-US" sz="900" dirty="0"/>
-          </a:p>
-        </p:txBody>
-      </p:sp>
-      <p:sp>
-        <p:nvSpPr>
-          <p:cNvPr id="30" name="Tag box 2"/>
-          <p:cNvSpPr/>
-          <p:nvPr/>
-        </p:nvSpPr>
-        <p:spPr>
-          <a:xfrm>
-            <a:off x="5954573" y="1956816"/>
-            <a:ext cx="676656" cy="246888"/>
-          </a:xfrm>
-          <a:prstGeom prst="roundRect">
-            <a:avLst>
-              <a:gd name="adj" fmla="val 22222"/>
-            </a:avLst>
-          </a:prstGeom>
-          <a:solidFill>
-            <a:srgbClr val="E3EAF3"/>
-          </a:solidFill>
-          <a:ln w="12700">
-            <a:solidFill>
-              <a:srgbClr val="E3EAF3"/>
-            </a:solidFill>
-            <a:prstDash val="solid"/>
-          </a:ln>
-        </p:spPr>
-        <p:txBody>
-          <a:bodyPr/>
-          <a:lstStyle/>
-          <a:p>
-            <a:endParaRPr lang="zh-TW" altLang="en-US"/>
-          </a:p>
-        </p:txBody>
-      </p:sp>
-      <p:sp>
-        <p:nvSpPr>
-          <p:cNvPr id="31" name="Tag text 2"/>
-          <p:cNvSpPr txBox="1"/>
-          <p:nvPr/>
-        </p:nvSpPr>
-        <p:spPr>
-          <a:xfrm>
-            <a:off x="5954573" y="1956816"/>
-            <a:ext cx="676656" cy="246888"/>
-          </a:xfrm>
-          <a:prstGeom prst="rect">
-            <a:avLst/>
-          </a:prstGeom>
-          <a:noFill/>
-          <a:ln/>
-        </p:spPr>
-        <p:txBody>
-          <a:bodyPr wrap="square" lIns="0" tIns="0" rIns="0" bIns="0" rtlCol="0" anchor="ctr"/>
-          <a:lstStyle/>
-          <a:p>
-            <a:pPr marL="0" indent="0" algn="ctr" eaLnBrk="1" latinLnBrk="0" hangingPunct="1">
-              <a:buNone/>
-            </a:pPr>
-            <a:r>
-              <a:rPr lang="zh-TW" altLang="en-US" sz="900" dirty="0">
-                <a:solidFill>
-                  <a:srgbClr val="1F3A5F"/>
-                </a:solidFill>
-                <a:latin typeface="Microsoft JhengHei" pitchFamily="34" charset="0"/>
-                <a:ea typeface="Microsoft JhengHei" pitchFamily="34" charset="-120"/>
-                <a:cs typeface="Microsoft JhengHei" pitchFamily="34" charset="-120"/>
-              </a:rPr>
-              <a:t>團隊領導</a:t>
+              <a:t>團隊合作</a:t>
             </a:r>
             <a:endParaRPr lang="zh-TW" altLang="en-US" sz="900" dirty="0"/>
           </a:p>
@@ -5943,7 +5610,7 @@
                 <a:ea typeface="Microsoft JhengHei" pitchFamily="34" charset="-120"/>
                 <a:cs typeface="Microsoft JhengHei" pitchFamily="34" charset="-120"/>
               </a:rPr>
-              <a:t>2025 東京威力科創機器人大賽（TEL Robot Combat）要在短時間內從零做出一台射球機器人，把球射進九宮格靶孔。我是四人隊伍的隊長，負責整台的硬體架構、機構與電路設計，也帶團隊分工。</a:t>
+              <a:t>2025 東京威力科創機器人大賽（TEL Robot Combat）要在三個月內從零做出一台自動射球機器人，把球射進九宮格靶孔。我是四人隊伍的隊長，負責整台的硬體架構、機構與電路設計，也帶團隊分工。</a:t>
             </a:r>
             <a:endParaRPr lang="zh-TW" altLang="en-US" sz="1050" dirty="0"/>
           </a:p>
@@ -6593,7 +6260,7 @@
                 <a:ea typeface="Microsoft JhengHei" pitchFamily="34" charset="-120"/>
                 <a:cs typeface="Microsoft JhengHei" pitchFamily="34" charset="-120"/>
               </a:rPr>
-              <a:t>雙飛輪發射</a:t>
+              <a:t>無刷雙飛輪發射</a:t>
             </a:r>
             <a:endParaRPr lang="zh-TW" altLang="en-US" sz="950" dirty="0"/>
           </a:p>
@@ -9215,14 +8882,15 @@
         </p:nvPicPr>
         <p:blipFill>
           <a:blip r:embed="rId3"/>
+          <a:srcRect t="7639" b="7489"/>
           <a:stretch>
             <a:fillRect/>
           </a:stretch>
         </p:blipFill>
         <p:spPr>
           <a:xfrm>
-            <a:off x="1124512" y="5811012"/>
-            <a:ext cx="2419304" cy="3291840"/>
+            <a:off x="548640" y="7517875"/>
+            <a:ext cx="2419304" cy="2793854"/>
           </a:xfrm>
           <a:prstGeom prst="rect">
             <a:avLst/>
@@ -9239,14 +8907,15 @@
         </p:nvPicPr>
         <p:blipFill>
           <a:blip r:embed="rId4"/>
+          <a:srcRect t="-1" b="15128"/>
           <a:stretch>
             <a:fillRect/>
           </a:stretch>
         </p:blipFill>
         <p:spPr>
           <a:xfrm>
-            <a:off x="3955296" y="5811012"/>
-            <a:ext cx="2476793" cy="3291840"/>
+            <a:off x="3842766" y="7517333"/>
+            <a:ext cx="2476793" cy="2793855"/>
           </a:xfrm>
           <a:prstGeom prst="rect">
             <a:avLst/>
@@ -9261,7 +8930,7 @@
         </p:nvSpPr>
         <p:spPr>
           <a:xfrm>
-            <a:off x="1124512" y="9157716"/>
+            <a:off x="483297" y="10384882"/>
             <a:ext cx="2419304" cy="237744"/>
           </a:xfrm>
           <a:prstGeom prst="rect">
@@ -9300,7 +8969,7 @@
         </p:nvSpPr>
         <p:spPr>
           <a:xfrm>
-            <a:off x="3955296" y="9157716"/>
+            <a:off x="3900261" y="10373782"/>
             <a:ext cx="2476793" cy="237744"/>
           </a:xfrm>
           <a:prstGeom prst="rect">
@@ -9331,6 +9000,36 @@
           </a:p>
         </p:txBody>
       </p:sp>
+      <p:pic>
+        <p:nvPicPr>
+          <p:cNvPr id="26" name="image14.png">
+            <a:extLst>
+              <a:ext uri="{FF2B5EF4-FFF2-40B4-BE49-F238E27FC236}">
+                <a16:creationId xmlns:a16="http://schemas.microsoft.com/office/drawing/2014/main" id="{6BD09F2F-EAB0-A942-7093-28A1763FCAEA}"/>
+              </a:ext>
+            </a:extLst>
+          </p:cNvPr>
+          <p:cNvPicPr/>
+          <p:nvPr/>
+        </p:nvPicPr>
+        <p:blipFill>
+          <a:blip r:embed="rId5"/>
+          <a:srcRect/>
+          <a:stretch>
+            <a:fillRect/>
+          </a:stretch>
+        </p:blipFill>
+        <p:spPr>
+          <a:xfrm>
+            <a:off x="1975727" y="5353050"/>
+            <a:ext cx="3605045" cy="1967538"/>
+          </a:xfrm>
+          <a:prstGeom prst="rect">
+            <a:avLst/>
+          </a:prstGeom>
+          <a:ln/>
+        </p:spPr>
+      </p:pic>
     </p:spTree>
   </p:cSld>
   <p:clrMapOvr>

</xml_diff>

<commit_message>
Make CV slide 2 pipeline editable and drop the sim replay image
- Rebuild the pipeline screenshot as native shapes: six cards (title +
  tool label + cropped screenshot) in a 2x3 grid, straight arrows within
  rows and an editable wrap-around connector between rows, grouped so it
  moves as one unit.
- Remove the Episode replay image and its caption; section 01 text now
  spans the full width and the demo link moves into the section heading.
- Section 02 moves up to fill the freed space. Unused media parts removed.

Co-Authored-By: Claude Opus 5.5 <noreply@anthropic.com>
Claude-Session: https://claude.ai/code/session_01X2qFQGQaWjMneKihQ62xc2
</commit_message>
<xml_diff>
--- a/CV_updated.pptx
+++ b/CV_updated.pptx
@@ -4065,7 +4065,7 @@
         </p:nvSpPr>
         <p:spPr>
           <a:xfrm>
-            <a:off x="548640" y="3017520"/>
+            <a:off x="548640" y="2999232"/>
             <a:ext cx="365760" cy="256032"/>
           </a:xfrm>
           <a:prstGeom prst="roundRect">
@@ -4099,7 +4099,7 @@
         </p:nvSpPr>
         <p:spPr>
           <a:xfrm>
-            <a:off x="548640" y="3017520"/>
+            <a:off x="548640" y="2999232"/>
             <a:ext cx="365760" cy="256032"/>
           </a:xfrm>
           <a:prstGeom prst="rect">
@@ -4141,7 +4141,7 @@
         </p:nvSpPr>
         <p:spPr>
           <a:xfrm>
-            <a:off x="1024128" y="3017520"/>
+            <a:off x="1024128" y="2999232"/>
             <a:ext cx="3840480" cy="256032"/>
           </a:xfrm>
           <a:prstGeom prst="rect">
@@ -4183,8 +4183,8 @@
         </p:nvSpPr>
         <p:spPr>
           <a:xfrm>
-            <a:off x="4626864" y="3017520"/>
-            <a:ext cx="2377440" cy="256032"/>
+            <a:off x="4261104" y="2999232"/>
+            <a:ext cx="2743200" cy="256032"/>
           </a:xfrm>
           <a:prstGeom prst="rect">
             <a:avLst/>
@@ -4203,17 +4203,18 @@
               <a:buNone/>
             </a:pPr>
             <a:r>
-              <a:rPr lang="zh-TW" altLang="en-US" sz="950" dirty="0">
-                <a:solidFill>
-                  <a:srgbClr val="5F6B7A"/>
-                </a:solidFill>
-                <a:latin typeface="Microsoft JhengHei" pitchFamily="34" charset="0"/>
-                <a:ea typeface="Microsoft JhengHei" pitchFamily="34" charset="-120"/>
-                <a:cs typeface="Microsoft JhengHei" pitchFamily="34" charset="-120"/>
-              </a:rPr>
-              <a:t>雙手交接任務  ·  模擬到真機</a:t>
-            </a:r>
-            <a:endParaRPr lang="zh-TW" altLang="en-US" sz="950" dirty="0"/>
+              <a:rPr lang="zh-TW" altLang="en-US" sz="900" b="1" u="sng" dirty="0">
+                <a:solidFill>
+                  <a:srgbClr val="1F3A5F"/>
+                </a:solidFill>
+                <a:latin typeface="Microsoft JhengHei" pitchFamily="34" charset="0"/>
+                <a:ea typeface="Microsoft JhengHei" pitchFamily="34" charset="-120"/>
+                <a:cs typeface="Microsoft JhengHei" pitchFamily="34" charset="-120"/>
+                <a:hlinkClick r:id="rId6"/>
+              </a:rPr>
+              <a:t>▶ Demo 影片：youtu.be/BDO_n6OTzGI</a:t>
+            </a:r>
+            <a:endParaRPr lang="zh-TW" altLang="en-US" sz="900" dirty="0"/>
           </a:p>
         </p:txBody>
       </p:sp>
@@ -4225,8 +4226,8 @@
         </p:nvSpPr>
         <p:spPr>
           <a:xfrm>
-            <a:off x="548640" y="3383280"/>
-            <a:ext cx="4261104" cy="1600200"/>
+            <a:off x="548640" y="3364992"/>
+            <a:ext cx="6455664" cy="1188720"/>
           </a:xfrm>
           <a:prstGeom prst="rect">
             <a:avLst/>
@@ -4307,154 +4308,866 @@
           </a:p>
         </p:txBody>
       </p:sp>
-      <p:pic>
-        <p:nvPicPr>
-          <p:cNvPr id="41" name="Image 0" descr="isaac"/>
-          <p:cNvPicPr>
-            <a:picLocks noChangeAspect="1"/>
-          </p:cNvPicPr>
-          <p:nvPr/>
-        </p:nvPicPr>
-        <p:blipFill>
-          <a:blip r:embed="rId3"/>
-          <a:stretch>
-            <a:fillRect/>
-          </a:stretch>
-        </p:blipFill>
-        <p:spPr>
-          <a:xfrm>
-            <a:off x="5084064" y="3383280"/>
-            <a:ext cx="1920240" cy="1515798"/>
-          </a:xfrm>
-          <a:prstGeom prst="rect">
-            <a:avLst/>
-          </a:prstGeom>
-        </p:spPr>
-      </p:pic>
-      <p:sp>
-        <p:nvSpPr>
-          <p:cNvPr id="43" name="Text 39"/>
-          <p:cNvSpPr txBox="1"/>
-          <p:nvPr/>
-        </p:nvSpPr>
-        <p:spPr>
-          <a:xfrm>
-            <a:off x="5084064" y="4935654"/>
-            <a:ext cx="1920240" cy="201168"/>
-          </a:xfrm>
-          <a:prstGeom prst="rect">
-            <a:avLst/>
-          </a:prstGeom>
-          <a:noFill/>
-          <a:ln/>
-        </p:spPr>
-        <p:txBody>
-          <a:bodyPr wrap="square" lIns="0" tIns="0" rIns="0" bIns="0" rtlCol="0" anchor="t"/>
-          <a:lstStyle/>
-          <a:p>
-            <a:pPr marL="0" indent="0" algn="ctr" eaLnBrk="1" latinLnBrk="0" hangingPunct="1">
-              <a:buNone/>
-            </a:pPr>
-            <a:r>
-              <a:rPr lang="zh-TW" altLang="en-US" sz="950" dirty="0">
-                <a:solidFill>
-                  <a:srgbClr val="5F6B7A"/>
-                </a:solidFill>
-                <a:latin typeface="Microsoft JhengHei" pitchFamily="34" charset="0"/>
-                <a:ea typeface="Microsoft JhengHei" pitchFamily="34" charset="-120"/>
-                <a:cs typeface="Microsoft JhengHei" pitchFamily="34" charset="-120"/>
-              </a:rPr>
-              <a:t>Episode replay in Isaac Sim</a:t>
-            </a:r>
-            <a:endParaRPr lang="zh-TW" altLang="en-US" sz="950" dirty="0"/>
-          </a:p>
-        </p:txBody>
-      </p:sp>
-      <p:pic>
-        <p:nvPicPr>
-          <p:cNvPr id="50" name="圖片 49">
-            <a:extLst>
-              <a:ext uri="{FF2B5EF4-FFF2-40B4-BE49-F238E27FC236}">
-                <a16:creationId xmlns:a16="http://schemas.microsoft.com/office/drawing/2014/main" id="{0451FF51-C242-5E4C-D7C5-82851BA75F38}"/>
-              </a:ext>
-            </a:extLst>
-          </p:cNvPr>
-          <p:cNvPicPr>
-            <a:picLocks noChangeAspect="1"/>
-          </p:cNvPicPr>
-          <p:nvPr/>
-        </p:nvPicPr>
-        <p:blipFill>
-          <a:blip r:embed="rId5"/>
-          <a:srcRect l="1296" r="1892"/>
-          <a:stretch>
-            <a:fillRect/>
-          </a:stretch>
-        </p:blipFill>
-        <p:spPr>
-          <a:xfrm>
-            <a:off x="1353312" y="5340096"/>
-            <a:ext cx="4846320" cy="1931507"/>
-          </a:xfrm>
-          <a:prstGeom prst="rect">
-            <a:avLst/>
-          </a:prstGeom>
-        </p:spPr>
-      </p:pic>
-      <p:sp>
-        <p:nvSpPr>
-          <p:cNvPr id="57" name="Pipeline caption"/>
-          <p:cNvSpPr txBox="1"/>
-          <p:nvPr/>
-        </p:nvSpPr>
-        <p:spPr>
-          <a:xfrm>
-            <a:off x="548640" y="7317323"/>
-            <a:ext cx="6455664" cy="201168"/>
-          </a:xfrm>
-          <a:prstGeom prst="rect">
-            <a:avLst/>
-          </a:prstGeom>
-          <a:noFill/>
-          <a:ln/>
-        </p:spPr>
-        <p:txBody>
-          <a:bodyPr wrap="square" lIns="0" tIns="0" rIns="0" bIns="0" rtlCol="0" anchor="t"/>
-          <a:lstStyle/>
-          <a:p>
-            <a:pPr marL="0" indent="0" algn="ctr" eaLnBrk="1" latinLnBrk="0" hangingPunct="1">
-              <a:lnSpc>
-                <a:spcPct val="100000"/>
-              </a:lnSpc>
-              <a:buNone/>
-            </a:pPr>
-            <a:r>
-              <a:rPr lang="zh-TW" altLang="en-US" sz="900" dirty="0">
-                <a:solidFill>
-                  <a:srgbClr val="5F6B7A"/>
-                </a:solidFill>
-                <a:latin typeface="Microsoft JhengHei" pitchFamily="34" charset="0"/>
-                <a:ea typeface="Microsoft JhengHei" pitchFamily="34" charset="-120"/>
-                <a:cs typeface="Microsoft JhengHei" pitchFamily="34" charset="-120"/>
-              </a:rPr>
-              <a:t>遙操作、資料擴增到模擬與真機評估的完整流程     </a:t>
-            </a:r>
-            <a:r>
-              <a:rPr lang="zh-TW" altLang="en-US" sz="900" b="1" u="sng" dirty="0">
-                <a:solidFill>
-                  <a:srgbClr val="1F3A5F"/>
-                </a:solidFill>
-                <a:latin typeface="Microsoft JhengHei" pitchFamily="34" charset="0"/>
-                <a:ea typeface="Microsoft JhengHei" pitchFamily="34" charset="-120"/>
-                <a:cs typeface="Microsoft JhengHei" pitchFamily="34" charset="-120"/>
-                <a:hlinkClick r:id="rId6"/>
-              </a:rPr>
-              <a:t>▶ Demo 影片：youtu.be/BDO_n6OTzGI</a:t>
-            </a:r>
-            <a:endParaRPr lang="zh-TW" altLang="en-US" sz="900" dirty="0"/>
-          </a:p>
-        </p:txBody>
-      </p:sp>
+      <p:grpSp>
+        <p:nvGrpSpPr>
+          <p:cNvPr id="88" name="Pipeline"/>
+          <p:cNvGrpSpPr/>
+          <p:nvPr/>
+        </p:nvGrpSpPr>
+        <p:grpSpPr>
+          <a:xfrm>
+            <a:off x="548640" y="4663440"/>
+            <a:ext cx="6455664" cy="2809148"/>
+            <a:chOff x="548640" y="4663440"/>
+            <a:chExt cx="6455664" cy="2809148"/>
+          </a:xfrm>
+        </p:grpSpPr>
+        <p:sp>
+          <p:nvSpPr>
+            <p:cNvPr id="65" name="Step 1 card"/>
+            <p:cNvSpPr/>
+            <p:nvPr/>
+          </p:nvSpPr>
+          <p:spPr>
+            <a:xfrm>
+              <a:off x="548640" y="4663440"/>
+              <a:ext cx="1969008" cy="1267414"/>
+            </a:xfrm>
+            <a:prstGeom prst="roundRect">
+              <a:avLst>
+                <a:gd name="adj" fmla="val 6000"/>
+              </a:avLst>
+            </a:prstGeom>
+            <a:solidFill>
+              <a:srgbClr val="FFFFFF"/>
+            </a:solidFill>
+            <a:ln w="9525">
+              <a:solidFill>
+                <a:srgbClr val="C9D1DC"/>
+              </a:solidFill>
+              <a:prstDash val="solid"/>
+            </a:ln>
+          </p:spPr>
+          <p:txBody>
+            <a:bodyPr/>
+            <a:lstStyle/>
+            <a:p>
+              <a:endParaRPr lang="zh-TW" altLang="en-US"/>
+            </a:p>
+          </p:txBody>
+        </p:sp>
+        <p:sp>
+          <p:nvSpPr>
+            <p:cNvPr id="66" name="Step 1 title"/>
+            <p:cNvSpPr txBox="1"/>
+            <p:nvPr/>
+          </p:nvSpPr>
+          <p:spPr>
+            <a:xfrm>
+              <a:off x="640080" y="4736592"/>
+              <a:ext cx="1804416" cy="292608"/>
+            </a:xfrm>
+            <a:prstGeom prst="rect">
+              <a:avLst/>
+            </a:prstGeom>
+            <a:noFill/>
+            <a:ln/>
+          </p:spPr>
+          <p:txBody>
+            <a:bodyPr wrap="square" lIns="0" tIns="0" rIns="0" bIns="0" rtlCol="0" anchor="ctr"/>
+            <a:lstStyle/>
+            <a:p>
+              <a:pPr marL="0" indent="0" eaLnBrk="1" latinLnBrk="0" hangingPunct="1">
+                <a:lnSpc>
+                  <a:spcPct val="100000"/>
+                </a:lnSpc>
+                <a:buNone/>
+              </a:pPr>
+              <a:r>
+                <a:rPr lang="zh-TW" altLang="en-US" sz="950" b="1" dirty="0">
+                  <a:solidFill>
+                    <a:srgbClr val="1F3A5F"/>
+                  </a:solidFill>
+                  <a:latin typeface="Microsoft JhengHei" pitchFamily="34" charset="0"/>
+                  <a:ea typeface="Microsoft JhengHei" pitchFamily="34" charset="-120"/>
+                  <a:cs typeface="Microsoft JhengHei" pitchFamily="34" charset="-120"/>
+                </a:rPr>
+                <a:t>任務設置</a:t>
+              </a:r>
+              <a:r>
+                <a:rPr lang="zh-TW" altLang="en-US" sz="800" dirty="0">
+                  <a:solidFill>
+                    <a:srgbClr val="5F6B7A"/>
+                  </a:solidFill>
+                  <a:latin typeface="Microsoft JhengHei" pitchFamily="34" charset="0"/>
+                  <a:ea typeface="Microsoft JhengHei" pitchFamily="34" charset="-120"/>
+                  <a:cs typeface="Microsoft JhengHei" pitchFamily="34" charset="-120"/>
+                </a:rPr>
+                <a:t>   Real World</a:t>
+              </a:r>
+              <a:endParaRPr lang="zh-TW" altLang="en-US" sz="950" dirty="0"/>
+            </a:p>
+          </p:txBody>
+        </p:sp>
+        <p:pic>
+          <p:nvPicPr>
+            <p:cNvPr id="67" name="Step 1 image" descr="任務設置 (Real World)"/>
+            <p:cNvPicPr>
+              <a:picLocks noChangeAspect="1"/>
+            </p:cNvPicPr>
+            <p:nvPr/>
+          </p:nvPicPr>
+          <p:blipFill>
+            <a:blip r:embed="rId7"/>
+            <a:srcRect l="0" t="8000" r="0" b="10000"/>
+            <a:stretch>
+              <a:fillRect/>
+            </a:stretch>
+          </p:blipFill>
+          <p:spPr>
+            <a:xfrm>
+              <a:off x="621792" y="5029200"/>
+              <a:ext cx="1822704" cy="828502"/>
+            </a:xfrm>
+            <a:prstGeom prst="rect">
+              <a:avLst/>
+            </a:prstGeom>
+            <a:ln w="6350">
+              <a:solidFill>
+                <a:srgbClr val="DDE3EA"/>
+              </a:solidFill>
+            </a:ln>
+          </p:spPr>
+        </p:pic>
+        <p:sp>
+          <p:nvSpPr>
+            <p:cNvPr id="68" name="Step 2 card"/>
+            <p:cNvSpPr/>
+            <p:nvPr/>
+          </p:nvSpPr>
+          <p:spPr>
+            <a:xfrm>
+              <a:off x="2791968" y="4663440"/>
+              <a:ext cx="1969008" cy="1267414"/>
+            </a:xfrm>
+            <a:prstGeom prst="roundRect">
+              <a:avLst>
+                <a:gd name="adj" fmla="val 6000"/>
+              </a:avLst>
+            </a:prstGeom>
+            <a:solidFill>
+              <a:srgbClr val="EAF6EC"/>
+            </a:solidFill>
+            <a:ln w="9525">
+              <a:solidFill>
+                <a:srgbClr val="BCDCC4"/>
+              </a:solidFill>
+              <a:prstDash val="solid"/>
+            </a:ln>
+          </p:spPr>
+          <p:txBody>
+            <a:bodyPr/>
+            <a:lstStyle/>
+            <a:p>
+              <a:endParaRPr lang="zh-TW" altLang="en-US"/>
+            </a:p>
+          </p:txBody>
+        </p:sp>
+        <p:sp>
+          <p:nvSpPr>
+            <p:cNvPr id="69" name="Step 2 title"/>
+            <p:cNvSpPr txBox="1"/>
+            <p:nvPr/>
+          </p:nvSpPr>
+          <p:spPr>
+            <a:xfrm>
+              <a:off x="2883408" y="4736592"/>
+              <a:ext cx="1804416" cy="292608"/>
+            </a:xfrm>
+            <a:prstGeom prst="rect">
+              <a:avLst/>
+            </a:prstGeom>
+            <a:noFill/>
+            <a:ln/>
+          </p:spPr>
+          <p:txBody>
+            <a:bodyPr wrap="square" lIns="0" tIns="0" rIns="0" bIns="0" rtlCol="0" anchor="ctr"/>
+            <a:lstStyle/>
+            <a:p>
+              <a:pPr marL="0" indent="0" eaLnBrk="1" latinLnBrk="0" hangingPunct="1">
+                <a:lnSpc>
+                  <a:spcPct val="100000"/>
+                </a:lnSpc>
+                <a:buNone/>
+              </a:pPr>
+              <a:r>
+                <a:rPr lang="zh-TW" altLang="en-US" sz="950" b="1" dirty="0">
+                  <a:solidFill>
+                    <a:srgbClr val="1F3A5F"/>
+                  </a:solidFill>
+                  <a:latin typeface="Microsoft JhengHei" pitchFamily="34" charset="0"/>
+                  <a:ea typeface="Microsoft JhengHei" pitchFamily="34" charset="-120"/>
+                  <a:cs typeface="Microsoft JhengHei" pitchFamily="34" charset="-120"/>
+                </a:rPr>
+                <a:t>VR 遙操作</a:t>
+              </a:r>
+              <a:r>
+                <a:rPr lang="zh-TW" altLang="en-US" sz="800" dirty="0">
+                  <a:solidFill>
+                    <a:srgbClr val="5F6B7A"/>
+                  </a:solidFill>
+                  <a:latin typeface="Microsoft JhengHei" pitchFamily="34" charset="0"/>
+                  <a:ea typeface="Microsoft JhengHei" pitchFamily="34" charset="-120"/>
+                  <a:cs typeface="Microsoft JhengHei" pitchFamily="34" charset="-120"/>
+                </a:rPr>
+                <a:t>   Isaac Sim</a:t>
+              </a:r>
+              <a:endParaRPr lang="zh-TW" altLang="en-US" sz="950" dirty="0"/>
+            </a:p>
+          </p:txBody>
+        </p:sp>
+        <p:pic>
+          <p:nvPicPr>
+            <p:cNvPr id="70" name="Step 2 image" descr="VR 遙操作 (Isaac Sim)"/>
+            <p:cNvPicPr>
+              <a:picLocks noChangeAspect="1"/>
+            </p:cNvPicPr>
+            <p:nvPr/>
+          </p:nvPicPr>
+          <p:blipFill>
+            <a:blip r:embed="rId8"/>
+            <a:srcRect l="0" t="8000" r="0" b="4400"/>
+            <a:stretch>
+              <a:fillRect/>
+            </a:stretch>
+          </p:blipFill>
+          <p:spPr>
+            <a:xfrm>
+              <a:off x="2865120" y="5029200"/>
+              <a:ext cx="1822704" cy="828502"/>
+            </a:xfrm>
+            <a:prstGeom prst="rect">
+              <a:avLst/>
+            </a:prstGeom>
+            <a:ln w="6350">
+              <a:solidFill>
+                <a:srgbClr val="DDE3EA"/>
+              </a:solidFill>
+            </a:ln>
+          </p:spPr>
+        </p:pic>
+        <p:sp>
+          <p:nvSpPr>
+            <p:cNvPr id="71" name="Step 3 card"/>
+            <p:cNvSpPr/>
+            <p:nvPr/>
+          </p:nvSpPr>
+          <p:spPr>
+            <a:xfrm>
+              <a:off x="5035296" y="4663440"/>
+              <a:ext cx="1969008" cy="1267414"/>
+            </a:xfrm>
+            <a:prstGeom prst="roundRect">
+              <a:avLst>
+                <a:gd name="adj" fmla="val 6000"/>
+              </a:avLst>
+            </a:prstGeom>
+            <a:solidFill>
+              <a:srgbClr val="EAF6EC"/>
+            </a:solidFill>
+            <a:ln w="9525">
+              <a:solidFill>
+                <a:srgbClr val="BCDCC4"/>
+              </a:solidFill>
+              <a:prstDash val="solid"/>
+            </a:ln>
+          </p:spPr>
+          <p:txBody>
+            <a:bodyPr/>
+            <a:lstStyle/>
+            <a:p>
+              <a:endParaRPr lang="zh-TW" altLang="en-US"/>
+            </a:p>
+          </p:txBody>
+        </p:sp>
+        <p:sp>
+          <p:nvSpPr>
+            <p:cNvPr id="72" name="Step 3 title"/>
+            <p:cNvSpPr txBox="1"/>
+            <p:nvPr/>
+          </p:nvSpPr>
+          <p:spPr>
+            <a:xfrm>
+              <a:off x="5126736" y="4736592"/>
+              <a:ext cx="1804416" cy="292608"/>
+            </a:xfrm>
+            <a:prstGeom prst="rect">
+              <a:avLst/>
+            </a:prstGeom>
+            <a:noFill/>
+            <a:ln/>
+          </p:spPr>
+          <p:txBody>
+            <a:bodyPr wrap="square" lIns="0" tIns="0" rIns="0" bIns="0" rtlCol="0" anchor="ctr"/>
+            <a:lstStyle/>
+            <a:p>
+              <a:pPr marL="0" indent="0" eaLnBrk="1" latinLnBrk="0" hangingPunct="1">
+                <a:lnSpc>
+                  <a:spcPct val="100000"/>
+                </a:lnSpc>
+                <a:buNone/>
+              </a:pPr>
+              <a:r>
+                <a:rPr lang="zh-TW" altLang="en-US" sz="950" b="1" dirty="0">
+                  <a:solidFill>
+                    <a:srgbClr val="1F3A5F"/>
+                  </a:solidFill>
+                  <a:latin typeface="Microsoft JhengHei" pitchFamily="34" charset="0"/>
+                  <a:ea typeface="Microsoft JhengHei" pitchFamily="34" charset="-120"/>
+                  <a:cs typeface="Microsoft JhengHei" pitchFamily="34" charset="-120"/>
+                </a:rPr>
+                <a:t>資料擴增</a:t>
+              </a:r>
+              <a:r>
+                <a:rPr lang="zh-TW" altLang="en-US" sz="800" dirty="0">
+                  <a:solidFill>
+                    <a:srgbClr val="5F6B7A"/>
+                  </a:solidFill>
+                  <a:latin typeface="Microsoft JhengHei" pitchFamily="34" charset="0"/>
+                  <a:ea typeface="Microsoft JhengHei" pitchFamily="34" charset="-120"/>
+                  <a:cs typeface="Microsoft JhengHei" pitchFamily="34" charset="-120"/>
+                </a:rPr>
+                <a:t>   Isaac Lab Mimic</a:t>
+              </a:r>
+              <a:endParaRPr lang="zh-TW" altLang="en-US" sz="950" dirty="0"/>
+            </a:p>
+          </p:txBody>
+        </p:sp>
+        <p:pic>
+          <p:nvPicPr>
+            <p:cNvPr id="73" name="Step 3 image" descr="資料擴增 (Isaac Lab Mimic)"/>
+            <p:cNvPicPr>
+              <a:picLocks noChangeAspect="1"/>
+            </p:cNvPicPr>
+            <p:nvPr/>
+          </p:nvPicPr>
+          <p:blipFill>
+            <a:blip r:embed="rId9"/>
+            <a:srcRect l="0" t="10000" r="0" b="4000"/>
+            <a:stretch>
+              <a:fillRect/>
+            </a:stretch>
+          </p:blipFill>
+          <p:spPr>
+            <a:xfrm>
+              <a:off x="5108448" y="5029200"/>
+              <a:ext cx="1822704" cy="828502"/>
+            </a:xfrm>
+            <a:prstGeom prst="rect">
+              <a:avLst/>
+            </a:prstGeom>
+            <a:ln w="6350">
+              <a:solidFill>
+                <a:srgbClr val="DDE3EA"/>
+              </a:solidFill>
+            </a:ln>
+          </p:spPr>
+        </p:pic>
+        <p:sp>
+          <p:nvSpPr>
+            <p:cNvPr id="74" name="Step 4 card"/>
+            <p:cNvSpPr/>
+            <p:nvPr/>
+          </p:nvSpPr>
+          <p:spPr>
+            <a:xfrm>
+              <a:off x="548640" y="6205174"/>
+              <a:ext cx="1969008" cy="1267414"/>
+            </a:xfrm>
+            <a:prstGeom prst="roundRect">
+              <a:avLst>
+                <a:gd name="adj" fmla="val 6000"/>
+              </a:avLst>
+            </a:prstGeom>
+            <a:solidFill>
+              <a:srgbClr val="FFF7E1"/>
+            </a:solidFill>
+            <a:ln w="9525">
+              <a:solidFill>
+                <a:srgbClr val="E8D6A2"/>
+              </a:solidFill>
+              <a:prstDash val="solid"/>
+            </a:ln>
+          </p:spPr>
+          <p:txBody>
+            <a:bodyPr/>
+            <a:lstStyle/>
+            <a:p>
+              <a:endParaRPr lang="zh-TW" altLang="en-US"/>
+            </a:p>
+          </p:txBody>
+        </p:sp>
+        <p:sp>
+          <p:nvSpPr>
+            <p:cNvPr id="75" name="Step 4 title"/>
+            <p:cNvSpPr txBox="1"/>
+            <p:nvPr/>
+          </p:nvSpPr>
+          <p:spPr>
+            <a:xfrm>
+              <a:off x="640080" y="6278326"/>
+              <a:ext cx="1804416" cy="292608"/>
+            </a:xfrm>
+            <a:prstGeom prst="rect">
+              <a:avLst/>
+            </a:prstGeom>
+            <a:noFill/>
+            <a:ln/>
+          </p:spPr>
+          <p:txBody>
+            <a:bodyPr wrap="square" lIns="0" tIns="0" rIns="0" bIns="0" rtlCol="0" anchor="ctr"/>
+            <a:lstStyle/>
+            <a:p>
+              <a:pPr marL="0" indent="0" eaLnBrk="1" latinLnBrk="0" hangingPunct="1">
+                <a:lnSpc>
+                  <a:spcPct val="100000"/>
+                </a:lnSpc>
+                <a:buNone/>
+              </a:pPr>
+              <a:r>
+                <a:rPr lang="zh-TW" altLang="en-US" sz="950" b="1" dirty="0">
+                  <a:solidFill>
+                    <a:srgbClr val="1F3A5F"/>
+                  </a:solidFill>
+                  <a:latin typeface="Microsoft JhengHei" pitchFamily="34" charset="0"/>
+                  <a:ea typeface="Microsoft JhengHei" pitchFamily="34" charset="-120"/>
+                  <a:cs typeface="Microsoft JhengHei" pitchFamily="34" charset="-120"/>
+                </a:rPr>
+                <a:t>模型訓練</a:t>
+              </a:r>
+              <a:r>
+                <a:rPr lang="zh-TW" altLang="en-US" sz="800" dirty="0">
+                  <a:solidFill>
+                    <a:srgbClr val="5F6B7A"/>
+                  </a:solidFill>
+                  <a:latin typeface="Microsoft JhengHei" pitchFamily="34" charset="0"/>
+                  <a:ea typeface="Microsoft JhengHei" pitchFamily="34" charset="-120"/>
+                  <a:cs typeface="Microsoft JhengHei" pitchFamily="34" charset="-120"/>
+                </a:rPr>
+                <a:t>   LeRobot · SmolVLA</a:t>
+              </a:r>
+              <a:endParaRPr lang="zh-TW" altLang="en-US" sz="950" dirty="0"/>
+            </a:p>
+          </p:txBody>
+        </p:sp>
+        <p:pic>
+          <p:nvPicPr>
+            <p:cNvPr id="76" name="Step 4 image" descr="模型訓練 (LeRobot · SmolVLA)"/>
+            <p:cNvPicPr>
+              <a:picLocks noChangeAspect="1"/>
+            </p:cNvPicPr>
+            <p:nvPr/>
+          </p:nvPicPr>
+          <p:blipFill>
+            <a:blip r:embed="rId10"/>
+            <a:srcRect l="6000" t="0" r="7700" b="0"/>
+            <a:stretch>
+              <a:fillRect/>
+            </a:stretch>
+          </p:blipFill>
+          <p:spPr>
+            <a:xfrm>
+              <a:off x="621792" y="6570934"/>
+              <a:ext cx="1822704" cy="828502"/>
+            </a:xfrm>
+            <a:prstGeom prst="rect">
+              <a:avLst/>
+            </a:prstGeom>
+            <a:ln w="6350">
+              <a:solidFill>
+                <a:srgbClr val="DDE3EA"/>
+              </a:solidFill>
+            </a:ln>
+          </p:spPr>
+        </p:pic>
+        <p:sp>
+          <p:nvSpPr>
+            <p:cNvPr id="77" name="Step 5 card"/>
+            <p:cNvSpPr/>
+            <p:nvPr/>
+          </p:nvSpPr>
+          <p:spPr>
+            <a:xfrm>
+              <a:off x="2791968" y="6205174"/>
+              <a:ext cx="1969008" cy="1267414"/>
+            </a:xfrm>
+            <a:prstGeom prst="roundRect">
+              <a:avLst>
+                <a:gd name="adj" fmla="val 6000"/>
+              </a:avLst>
+            </a:prstGeom>
+            <a:solidFill>
+              <a:srgbClr val="EAF6EC"/>
+            </a:solidFill>
+            <a:ln w="9525">
+              <a:solidFill>
+                <a:srgbClr val="BCDCC4"/>
+              </a:solidFill>
+              <a:prstDash val="solid"/>
+            </a:ln>
+          </p:spPr>
+          <p:txBody>
+            <a:bodyPr/>
+            <a:lstStyle/>
+            <a:p>
+              <a:endParaRPr lang="zh-TW" altLang="en-US"/>
+            </a:p>
+          </p:txBody>
+        </p:sp>
+        <p:sp>
+          <p:nvSpPr>
+            <p:cNvPr id="78" name="Step 5 title"/>
+            <p:cNvSpPr txBox="1"/>
+            <p:nvPr/>
+          </p:nvSpPr>
+          <p:spPr>
+            <a:xfrm>
+              <a:off x="2883408" y="6278326"/>
+              <a:ext cx="1804416" cy="292608"/>
+            </a:xfrm>
+            <a:prstGeom prst="rect">
+              <a:avLst/>
+            </a:prstGeom>
+            <a:noFill/>
+            <a:ln/>
+          </p:spPr>
+          <p:txBody>
+            <a:bodyPr wrap="square" lIns="0" tIns="0" rIns="0" bIns="0" rtlCol="0" anchor="ctr"/>
+            <a:lstStyle/>
+            <a:p>
+              <a:pPr marL="0" indent="0" eaLnBrk="1" latinLnBrk="0" hangingPunct="1">
+                <a:lnSpc>
+                  <a:spcPct val="100000"/>
+                </a:lnSpc>
+                <a:buNone/>
+              </a:pPr>
+              <a:r>
+                <a:rPr lang="zh-TW" altLang="en-US" sz="950" b="1" dirty="0">
+                  <a:solidFill>
+                    <a:srgbClr val="1F3A5F"/>
+                  </a:solidFill>
+                  <a:latin typeface="Microsoft JhengHei" pitchFamily="34" charset="0"/>
+                  <a:ea typeface="Microsoft JhengHei" pitchFamily="34" charset="-120"/>
+                  <a:cs typeface="Microsoft JhengHei" pitchFamily="34" charset="-120"/>
+                </a:rPr>
+                <a:t>模擬評估</a:t>
+              </a:r>
+              <a:r>
+                <a:rPr lang="zh-TW" altLang="en-US" sz="800" dirty="0">
+                  <a:solidFill>
+                    <a:srgbClr val="5F6B7A"/>
+                  </a:solidFill>
+                  <a:latin typeface="Microsoft JhengHei" pitchFamily="34" charset="0"/>
+                  <a:ea typeface="Microsoft JhengHei" pitchFamily="34" charset="-120"/>
+                  <a:cs typeface="Microsoft JhengHei" pitchFamily="34" charset="-120"/>
+                </a:rPr>
+                <a:t>   Isaac Sim</a:t>
+              </a:r>
+              <a:endParaRPr lang="zh-TW" altLang="en-US" sz="950" dirty="0"/>
+            </a:p>
+          </p:txBody>
+        </p:sp>
+        <p:pic>
+          <p:nvPicPr>
+            <p:cNvPr id="79" name="Step 5 image" descr="模擬評估 (Isaac Sim)"/>
+            <p:cNvPicPr>
+              <a:picLocks noChangeAspect="1"/>
+            </p:cNvPicPr>
+            <p:nvPr/>
+          </p:nvPicPr>
+          <p:blipFill>
+            <a:blip r:embed="rId11"/>
+            <a:srcRect l="0" t="9000" r="0" b="10000"/>
+            <a:stretch>
+              <a:fillRect/>
+            </a:stretch>
+          </p:blipFill>
+          <p:spPr>
+            <a:xfrm>
+              <a:off x="2865120" y="6570934"/>
+              <a:ext cx="1822704" cy="828502"/>
+            </a:xfrm>
+            <a:prstGeom prst="rect">
+              <a:avLst/>
+            </a:prstGeom>
+            <a:ln w="6350">
+              <a:solidFill>
+                <a:srgbClr val="DDE3EA"/>
+              </a:solidFill>
+            </a:ln>
+          </p:spPr>
+        </p:pic>
+        <p:sp>
+          <p:nvSpPr>
+            <p:cNvPr id="80" name="Step 6 card"/>
+            <p:cNvSpPr/>
+            <p:nvPr/>
+          </p:nvSpPr>
+          <p:spPr>
+            <a:xfrm>
+              <a:off x="5035296" y="6205174"/>
+              <a:ext cx="1969008" cy="1267414"/>
+            </a:xfrm>
+            <a:prstGeom prst="roundRect">
+              <a:avLst>
+                <a:gd name="adj" fmla="val 6000"/>
+              </a:avLst>
+            </a:prstGeom>
+            <a:solidFill>
+              <a:srgbClr val="FFFFFF"/>
+            </a:solidFill>
+            <a:ln w="9525">
+              <a:solidFill>
+                <a:srgbClr val="C9D1DC"/>
+              </a:solidFill>
+              <a:prstDash val="solid"/>
+            </a:ln>
+          </p:spPr>
+          <p:txBody>
+            <a:bodyPr/>
+            <a:lstStyle/>
+            <a:p>
+              <a:endParaRPr lang="zh-TW" altLang="en-US"/>
+            </a:p>
+          </p:txBody>
+        </p:sp>
+        <p:sp>
+          <p:nvSpPr>
+            <p:cNvPr id="81" name="Step 6 title"/>
+            <p:cNvSpPr txBox="1"/>
+            <p:nvPr/>
+          </p:nvSpPr>
+          <p:spPr>
+            <a:xfrm>
+              <a:off x="5126736" y="6278326"/>
+              <a:ext cx="1804416" cy="292608"/>
+            </a:xfrm>
+            <a:prstGeom prst="rect">
+              <a:avLst/>
+            </a:prstGeom>
+            <a:noFill/>
+            <a:ln/>
+          </p:spPr>
+          <p:txBody>
+            <a:bodyPr wrap="square" lIns="0" tIns="0" rIns="0" bIns="0" rtlCol="0" anchor="ctr"/>
+            <a:lstStyle/>
+            <a:p>
+              <a:pPr marL="0" indent="0" eaLnBrk="1" latinLnBrk="0" hangingPunct="1">
+                <a:lnSpc>
+                  <a:spcPct val="100000"/>
+                </a:lnSpc>
+                <a:buNone/>
+              </a:pPr>
+              <a:r>
+                <a:rPr lang="zh-TW" altLang="en-US" sz="950" b="1" dirty="0">
+                  <a:solidFill>
+                    <a:srgbClr val="1F3A5F"/>
+                  </a:solidFill>
+                  <a:latin typeface="Microsoft JhengHei" pitchFamily="34" charset="0"/>
+                  <a:ea typeface="Microsoft JhengHei" pitchFamily="34" charset="-120"/>
+                  <a:cs typeface="Microsoft JhengHei" pitchFamily="34" charset="-120"/>
+                </a:rPr>
+                <a:t>真機評估</a:t>
+              </a:r>
+              <a:r>
+                <a:rPr lang="zh-TW" altLang="en-US" sz="800" dirty="0">
+                  <a:solidFill>
+                    <a:srgbClr val="5F6B7A"/>
+                  </a:solidFill>
+                  <a:latin typeface="Microsoft JhengHei" pitchFamily="34" charset="0"/>
+                  <a:ea typeface="Microsoft JhengHei" pitchFamily="34" charset="-120"/>
+                  <a:cs typeface="Microsoft JhengHei" pitchFamily="34" charset="-120"/>
+                </a:rPr>
+                <a:t>   Real World</a:t>
+              </a:r>
+              <a:endParaRPr lang="zh-TW" altLang="en-US" sz="950" dirty="0"/>
+            </a:p>
+          </p:txBody>
+        </p:sp>
+        <p:pic>
+          <p:nvPicPr>
+            <p:cNvPr id="82" name="Step 6 image" descr="真機評估 (Real World)"/>
+            <p:cNvPicPr>
+              <a:picLocks noChangeAspect="1"/>
+            </p:cNvPicPr>
+            <p:nvPr/>
+          </p:nvPicPr>
+          <p:blipFill>
+            <a:blip r:embed="rId12"/>
+            <a:srcRect l="0" t="8000" r="0" b="8000"/>
+            <a:stretch>
+              <a:fillRect/>
+            </a:stretch>
+          </p:blipFill>
+          <p:spPr>
+            <a:xfrm>
+              <a:off x="5108448" y="6570934"/>
+              <a:ext cx="1822704" cy="828502"/>
+            </a:xfrm>
+            <a:prstGeom prst="rect">
+              <a:avLst/>
+            </a:prstGeom>
+            <a:ln w="6350">
+              <a:solidFill>
+                <a:srgbClr val="DDE3EA"/>
+              </a:solidFill>
+            </a:ln>
+          </p:spPr>
+        </p:pic>
+        <p:cxnSp>
+          <p:nvCxnSpPr>
+            <p:cNvPr id="83" name="Arrow 1-2"/>
+            <p:cNvCxnSpPr/>
+            <p:nvPr/>
+          </p:nvCxnSpPr>
+          <p:spPr>
+            <a:xfrm>
+              <a:off x="2563368" y="5443451"/>
+              <a:ext cx="182880" cy="0"/>
+            </a:xfrm>
+            <a:prstGeom prst="straightConnector1">
+              <a:avLst/>
+            </a:prstGeom>
+            <a:ln w="12700">
+              <a:solidFill>
+                <a:srgbClr val="8A94A3"/>
+              </a:solidFill>
+              <a:round/>
+              <a:tailEnd type="triangle" w="med" len="med"/>
+            </a:ln>
+          </p:spPr>
+        </p:cxnSp>
+        <p:cxnSp>
+          <p:nvCxnSpPr>
+            <p:cNvPr id="84" name="Arrow 2-3"/>
+            <p:cNvCxnSpPr/>
+            <p:nvPr/>
+          </p:nvCxnSpPr>
+          <p:spPr>
+            <a:xfrm>
+              <a:off x="4806696" y="5443451"/>
+              <a:ext cx="182880" cy="0"/>
+            </a:xfrm>
+            <a:prstGeom prst="straightConnector1">
+              <a:avLst/>
+            </a:prstGeom>
+            <a:ln w="12700">
+              <a:solidFill>
+                <a:srgbClr val="8A94A3"/>
+              </a:solidFill>
+              <a:round/>
+              <a:tailEnd type="triangle" w="med" len="med"/>
+            </a:ln>
+          </p:spPr>
+        </p:cxnSp>
+        <p:cxnSp>
+          <p:nvCxnSpPr>
+            <p:cNvPr id="85" name="Arrow 4-5"/>
+            <p:cNvCxnSpPr/>
+            <p:nvPr/>
+          </p:nvCxnSpPr>
+          <p:spPr>
+            <a:xfrm>
+              <a:off x="2563368" y="6985185"/>
+              <a:ext cx="182880" cy="0"/>
+            </a:xfrm>
+            <a:prstGeom prst="straightConnector1">
+              <a:avLst/>
+            </a:prstGeom>
+            <a:ln w="12700">
+              <a:solidFill>
+                <a:srgbClr val="8A94A3"/>
+              </a:solidFill>
+              <a:round/>
+              <a:tailEnd type="triangle" w="med" len="med"/>
+            </a:ln>
+          </p:spPr>
+        </p:cxnSp>
+        <p:cxnSp>
+          <p:nvCxnSpPr>
+            <p:cNvPr id="86" name="Arrow 5-6"/>
+            <p:cNvCxnSpPr/>
+            <p:nvPr/>
+          </p:nvCxnSpPr>
+          <p:spPr>
+            <a:xfrm>
+              <a:off x="4806696" y="6985185"/>
+              <a:ext cx="182880" cy="0"/>
+            </a:xfrm>
+            <a:prstGeom prst="straightConnector1">
+              <a:avLst/>
+            </a:prstGeom>
+            <a:ln w="12700">
+              <a:solidFill>
+                <a:srgbClr val="8A94A3"/>
+              </a:solidFill>
+              <a:round/>
+              <a:tailEnd type="triangle" w="med" len="med"/>
+            </a:ln>
+          </p:spPr>
+        </p:cxnSp>
+        <p:sp>
+          <p:nvSpPr>
+            <p:cNvPr id="87" name="Arrow 3-4"/>
+            <p:cNvSpPr/>
+            <p:nvPr/>
+          </p:nvSpPr>
+          <p:spPr>
+            <a:xfrm>
+              <a:off x="1533144" y="5930854"/>
+              <a:ext cx="4486656" cy="274320"/>
+            </a:xfrm>
+            <a:custGeom>
+              <a:avLst/>
+              <a:gdLst/>
+              <a:ahLst/>
+              <a:cxnLst/>
+              <a:rect l="l" t="t" r="r" b="b"/>
+              <a:pathLst>
+                <a:path w="4486656" h="274320" fill="none">
+                  <a:moveTo>
+                    <a:pt x="4486656" y="0"/>
+                  </a:moveTo>
+                  <a:lnTo>
+                    <a:pt x="4486656" y="137160"/>
+                  </a:lnTo>
+                  <a:lnTo>
+                    <a:pt x="0" y="137160"/>
+                  </a:lnTo>
+                  <a:lnTo>
+                    <a:pt x="0" y="274320"/>
+                  </a:lnTo>
+                </a:path>
+              </a:pathLst>
+            </a:custGeom>
+            <a:noFill/>
+            <a:ln w="12700">
+              <a:solidFill>
+                <a:srgbClr val="8A94A3"/>
+              </a:solidFill>
+              <a:round/>
+              <a:tailEnd type="triangle" w="med" len="med"/>
+            </a:ln>
+          </p:spPr>
+          <p:txBody>
+            <a:bodyPr/>
+            <a:lstStyle/>
+            <a:p>
+              <a:endParaRPr lang="zh-TW" altLang="en-US"/>
+            </a:p>
+          </p:txBody>
+        </p:sp>
+      </p:grpSp>
       <p:sp>
         <p:nvSpPr>
           <p:cNvPr id="58" name="S2 badge"/>
@@ -4463,7 +5176,7 @@
         </p:nvSpPr>
         <p:spPr>
           <a:xfrm>
-            <a:off x="548640" y="7662672"/>
+            <a:off x="548640" y="7710332"/>
             <a:ext cx="365760" cy="256032"/>
           </a:xfrm>
           <a:prstGeom prst="roundRect">
@@ -4497,7 +5210,7 @@
         </p:nvSpPr>
         <p:spPr>
           <a:xfrm>
-            <a:off x="548640" y="7662672"/>
+            <a:off x="548640" y="7710332"/>
             <a:ext cx="365760" cy="256032"/>
           </a:xfrm>
           <a:prstGeom prst="rect">
@@ -4539,7 +5252,7 @@
         </p:nvSpPr>
         <p:spPr>
           <a:xfrm>
-            <a:off x="1024128" y="7662672"/>
+            <a:off x="1024128" y="7710332"/>
             <a:ext cx="3840480" cy="256032"/>
           </a:xfrm>
           <a:prstGeom prst="rect">
@@ -4581,7 +5294,7 @@
         </p:nvSpPr>
         <p:spPr>
           <a:xfrm>
-            <a:off x="4626864" y="7662672"/>
+            <a:off x="4626864" y="7710332"/>
             <a:ext cx="2377440" cy="256032"/>
           </a:xfrm>
           <a:prstGeom prst="rect">
@@ -4631,8 +5344,8 @@
         </p:blipFill>
         <p:spPr>
           <a:xfrm>
-            <a:off x="548640" y="8028432"/>
-            <a:ext cx="1920240" cy="1846279"/>
+            <a:off x="548640" y="8076092"/>
+            <a:ext cx="1828800" cy="1758361"/>
           </a:xfrm>
           <a:prstGeom prst="rect">
             <a:avLst/>
@@ -4647,8 +5360,8 @@
         </p:nvSpPr>
         <p:spPr>
           <a:xfrm>
-            <a:off x="548640" y="9911287"/>
-            <a:ext cx="1920240" cy="201168"/>
+            <a:off x="548640" y="9871029"/>
+            <a:ext cx="1828800" cy="201168"/>
           </a:xfrm>
           <a:prstGeom prst="rect">
             <a:avLst/>
@@ -4686,8 +5399,8 @@
         </p:nvSpPr>
         <p:spPr>
           <a:xfrm>
-            <a:off x="2743200" y="8028432"/>
-            <a:ext cx="4261104" cy="960120"/>
+            <a:off x="2651760" y="8076092"/>
+            <a:ext cx="4352544" cy="960120"/>
           </a:xfrm>
           <a:prstGeom prst="rect">
             <a:avLst/>
@@ -4754,8 +5467,8 @@
         </p:nvSpPr>
         <p:spPr>
           <a:xfrm>
-            <a:off x="2743200" y="9198055"/>
-            <a:ext cx="4261104" cy="676656"/>
+            <a:off x="2651760" y="9194373"/>
+            <a:ext cx="4352544" cy="640080"/>
           </a:xfrm>
           <a:prstGeom prst="roundRect">
             <a:avLst>
@@ -4788,8 +5501,8 @@
         </p:nvSpPr>
         <p:spPr>
           <a:xfrm>
-            <a:off x="2907792" y="9198055"/>
-            <a:ext cx="3931920" cy="676656"/>
+            <a:off x="2816352" y="9194373"/>
+            <a:ext cx="4023360" cy="640080"/>
           </a:xfrm>
           <a:prstGeom prst="rect">
             <a:avLst/>

</xml_diff>

<commit_message>
Enlarge pipeline screenshots on CV slide 2
- Screenshots now fill nearly the full card width at a 1.8:1 ratio (close
  to their native ratio), about a third more area and far less cropping.
- SmolVLA banner padded with its own yellow instead of side-cropped.
- Tighter card padding/gaps; the method paragraph is shortened to two
  lines since the cards carry the step-by-step detail.

Co-Authored-By: Claude Opus 5.5 <noreply@anthropic.com>
Claude-Session: https://claude.ai/code/session_01X2qFQGQaWjMneKihQ62xc2
</commit_message>
<xml_diff>
--- a/CV_updated.pptx
+++ b/CV_updated.pptx
@@ -4227,7 +4227,7 @@
         <p:spPr>
           <a:xfrm>
             <a:off x="548640" y="3364992"/>
-            <a:ext cx="6455664" cy="1188720"/>
+            <a:ext cx="6455664" cy="960120"/>
           </a:xfrm>
           <a:prstGeom prst="rect">
             <a:avLst/>
@@ -4268,7 +4268,7 @@
                 <a:ea typeface="Microsoft JhengHei" pitchFamily="34" charset="-120"/>
                 <a:cs typeface="Microsoft JhengHei" pitchFamily="34" charset="-120"/>
               </a:rPr>
-              <a:t>考量時間和成本，我選擇用資料擴增來完成雙手交接任務：接上 VR 在 Isaac Sim 裡遙操作，錄了約 20 筆人類示範，用 Isaac Lab Mimic 擴增成上千筆訓練資料，轉成 LeRobot 資料集微調 SmolVLA，最後在模擬和真機上驗證。</a:t>
+              <a:t>考量時間和成本，我選擇用資料擴增來完成雙手交接任務：在 Isaac Sim 裡用 VR 遙操作錄約 20 筆人類示範，擴增成上千筆訓練資料後微調 SmolVLA，完整流程如下。</a:t>
             </a:r>
             <a:endParaRPr lang="zh-TW" altLang="en-US" sz="1050" dirty="0"/>
           </a:p>
@@ -4316,10 +4316,10 @@
         </p:nvGrpSpPr>
         <p:grpSpPr>
           <a:xfrm>
-            <a:off x="548640" y="4663440"/>
-            <a:ext cx="6455664" cy="2809148"/>
-            <a:chOff x="548640" y="4663440"/>
-            <a:chExt cx="6455664" cy="2809148"/>
+            <a:off x="548640" y="4443984"/>
+            <a:ext cx="6455664" cy="3096091"/>
+            <a:chOff x="548640" y="4443984"/>
+            <a:chExt cx="6455664" cy="3096091"/>
           </a:xfrm>
         </p:grpSpPr>
         <p:sp>
@@ -4330,8 +4330,8 @@
           </p:nvSpPr>
           <p:spPr>
             <a:xfrm>
-              <a:off x="548640" y="4663440"/>
-              <a:ext cx="1969008" cy="1267414"/>
+              <a:off x="548640" y="4443984"/>
+              <a:ext cx="2005584" cy="1429173"/>
             </a:xfrm>
             <a:prstGeom prst="roundRect">
               <a:avLst>
@@ -4364,8 +4364,8 @@
           </p:nvSpPr>
           <p:spPr>
             <a:xfrm>
-              <a:off x="640080" y="4736592"/>
-              <a:ext cx="1804416" cy="292608"/>
+              <a:off x="640080" y="4471416"/>
+              <a:ext cx="1868424" cy="274320"/>
             </a:xfrm>
             <a:prstGeom prst="rect">
               <a:avLst/>
@@ -4419,15 +4419,15 @@
           </p:nvPicPr>
           <p:blipFill>
             <a:blip r:embed="rId7"/>
-            <a:srcRect l="0" t="8000" r="0" b="10000"/>
+            <a:srcRect l="0" t="2122" r="0" b="2122"/>
             <a:stretch>
               <a:fillRect/>
             </a:stretch>
           </p:blipFill>
           <p:spPr>
             <a:xfrm>
-              <a:off x="621792" y="5029200"/>
-              <a:ext cx="1822704" cy="828502"/>
+              <a:off x="594360" y="4764024"/>
+              <a:ext cx="1914144" cy="1063413"/>
             </a:xfrm>
             <a:prstGeom prst="rect">
               <a:avLst/>
@@ -4447,8 +4447,8 @@
           </p:nvSpPr>
           <p:spPr>
             <a:xfrm>
-              <a:off x="2791968" y="4663440"/>
-              <a:ext cx="1969008" cy="1267414"/>
+              <a:off x="2773680" y="4443984"/>
+              <a:ext cx="2005584" cy="1429173"/>
             </a:xfrm>
             <a:prstGeom prst="roundRect">
               <a:avLst>
@@ -4481,8 +4481,8 @@
           </p:nvSpPr>
           <p:spPr>
             <a:xfrm>
-              <a:off x="2883408" y="4736592"/>
-              <a:ext cx="1804416" cy="292608"/>
+              <a:off x="2865120" y="4471416"/>
+              <a:ext cx="1868424" cy="274320"/>
             </a:xfrm>
             <a:prstGeom prst="rect">
               <a:avLst/>
@@ -4536,15 +4536,15 @@
           </p:nvPicPr>
           <p:blipFill>
             <a:blip r:embed="rId8"/>
-            <a:srcRect l="0" t="8000" r="0" b="4400"/>
+            <a:srcRect l="1131" t="0" r="1131" b="0"/>
             <a:stretch>
               <a:fillRect/>
             </a:stretch>
           </p:blipFill>
           <p:spPr>
             <a:xfrm>
-              <a:off x="2865120" y="5029200"/>
-              <a:ext cx="1822704" cy="828502"/>
+              <a:off x="2819400" y="4764024"/>
+              <a:ext cx="1914144" cy="1063413"/>
             </a:xfrm>
             <a:prstGeom prst="rect">
               <a:avLst/>
@@ -4564,8 +4564,8 @@
           </p:nvSpPr>
           <p:spPr>
             <a:xfrm>
-              <a:off x="5035296" y="4663440"/>
-              <a:ext cx="1969008" cy="1267414"/>
+              <a:off x="4998720" y="4443984"/>
+              <a:ext cx="2005584" cy="1429173"/>
             </a:xfrm>
             <a:prstGeom prst="roundRect">
               <a:avLst>
@@ -4598,8 +4598,8 @@
           </p:nvSpPr>
           <p:spPr>
             <a:xfrm>
-              <a:off x="5126736" y="4736592"/>
-              <a:ext cx="1804416" cy="292608"/>
+              <a:off x="5090160" y="4471416"/>
+              <a:ext cx="1868424" cy="274320"/>
             </a:xfrm>
             <a:prstGeom prst="rect">
               <a:avLst/>
@@ -4653,15 +4653,15 @@
           </p:nvPicPr>
           <p:blipFill>
             <a:blip r:embed="rId9"/>
-            <a:srcRect l="0" t="10000" r="0" b="4000"/>
+            <a:srcRect l="230" t="0" r="230" b="0"/>
             <a:stretch>
               <a:fillRect/>
             </a:stretch>
           </p:blipFill>
           <p:spPr>
             <a:xfrm>
-              <a:off x="5108448" y="5029200"/>
-              <a:ext cx="1822704" cy="828502"/>
+              <a:off x="5044440" y="4764024"/>
+              <a:ext cx="1914144" cy="1063413"/>
             </a:xfrm>
             <a:prstGeom prst="rect">
               <a:avLst/>
@@ -4681,8 +4681,8 @@
           </p:nvSpPr>
           <p:spPr>
             <a:xfrm>
-              <a:off x="548640" y="6205174"/>
-              <a:ext cx="1969008" cy="1267414"/>
+              <a:off x="548640" y="6110901"/>
+              <a:ext cx="2005584" cy="1429173"/>
             </a:xfrm>
             <a:prstGeom prst="roundRect">
               <a:avLst>
@@ -4715,8 +4715,8 @@
           </p:nvSpPr>
           <p:spPr>
             <a:xfrm>
-              <a:off x="640080" y="6278326"/>
-              <a:ext cx="1804416" cy="292608"/>
+              <a:off x="640080" y="6138333"/>
+              <a:ext cx="1868424" cy="274320"/>
             </a:xfrm>
             <a:prstGeom prst="rect">
               <a:avLst/>
@@ -4770,15 +4770,15 @@
           </p:nvPicPr>
           <p:blipFill>
             <a:blip r:embed="rId10"/>
-            <a:srcRect l="6000" t="0" r="7700" b="0"/>
+            <a:srcRect l="131" t="0" r="131" b="0"/>
             <a:stretch>
               <a:fillRect/>
             </a:stretch>
           </p:blipFill>
           <p:spPr>
             <a:xfrm>
-              <a:off x="621792" y="6570934"/>
-              <a:ext cx="1822704" cy="828502"/>
+              <a:off x="594360" y="6430941"/>
+              <a:ext cx="1914144" cy="1063413"/>
             </a:xfrm>
             <a:prstGeom prst="rect">
               <a:avLst/>
@@ -4798,8 +4798,8 @@
           </p:nvSpPr>
           <p:spPr>
             <a:xfrm>
-              <a:off x="2791968" y="6205174"/>
-              <a:ext cx="1969008" cy="1267414"/>
+              <a:off x="2773680" y="6110901"/>
+              <a:ext cx="2005584" cy="1429173"/>
             </a:xfrm>
             <a:prstGeom prst="roundRect">
               <a:avLst>
@@ -4832,8 +4832,8 @@
           </p:nvSpPr>
           <p:spPr>
             <a:xfrm>
-              <a:off x="2883408" y="6278326"/>
-              <a:ext cx="1804416" cy="292608"/>
+              <a:off x="2865120" y="6138333"/>
+              <a:ext cx="1868424" cy="274320"/>
             </a:xfrm>
             <a:prstGeom prst="rect">
               <a:avLst/>
@@ -4887,15 +4887,15 @@
           </p:nvPicPr>
           <p:blipFill>
             <a:blip r:embed="rId11"/>
-            <a:srcRect l="0" t="9000" r="0" b="10000"/>
+            <a:srcRect l="0" t="444" r="0" b="444"/>
             <a:stretch>
               <a:fillRect/>
             </a:stretch>
           </p:blipFill>
           <p:spPr>
             <a:xfrm>
-              <a:off x="2865120" y="6570934"/>
-              <a:ext cx="1822704" cy="828502"/>
+              <a:off x="2819400" y="6430941"/>
+              <a:ext cx="1914144" cy="1063413"/>
             </a:xfrm>
             <a:prstGeom prst="rect">
               <a:avLst/>
@@ -4915,8 +4915,8 @@
           </p:nvSpPr>
           <p:spPr>
             <a:xfrm>
-              <a:off x="5035296" y="6205174"/>
-              <a:ext cx="1969008" cy="1267414"/>
+              <a:off x="4998720" y="6110901"/>
+              <a:ext cx="2005584" cy="1429173"/>
             </a:xfrm>
             <a:prstGeom prst="roundRect">
               <a:avLst>
@@ -4949,8 +4949,8 @@
           </p:nvSpPr>
           <p:spPr>
             <a:xfrm>
-              <a:off x="5126736" y="6278326"/>
-              <a:ext cx="1804416" cy="292608"/>
+              <a:off x="5090160" y="6138333"/>
+              <a:ext cx="1868424" cy="274320"/>
             </a:xfrm>
             <a:prstGeom prst="rect">
               <a:avLst/>
@@ -5004,15 +5004,15 @@
           </p:nvPicPr>
           <p:blipFill>
             <a:blip r:embed="rId12"/>
-            <a:srcRect l="0" t="8000" r="0" b="8000"/>
+            <a:srcRect l="1052" t="0" r="1052" b="0"/>
             <a:stretch>
               <a:fillRect/>
             </a:stretch>
           </p:blipFill>
           <p:spPr>
             <a:xfrm>
-              <a:off x="5108448" y="6570934"/>
-              <a:ext cx="1822704" cy="828502"/>
+              <a:off x="5044440" y="6430941"/>
+              <a:ext cx="1914144" cy="1063413"/>
             </a:xfrm>
             <a:prstGeom prst="rect">
               <a:avLst/>
@@ -5032,8 +5032,8 @@
           </p:nvCxnSpPr>
           <p:spPr>
             <a:xfrm>
-              <a:off x="2563368" y="5443451"/>
-              <a:ext cx="182880" cy="0"/>
+              <a:off x="2590800" y="5295731"/>
+              <a:ext cx="146304" cy="0"/>
             </a:xfrm>
             <a:prstGeom prst="straightConnector1">
               <a:avLst/>
@@ -5055,8 +5055,8 @@
           </p:nvCxnSpPr>
           <p:spPr>
             <a:xfrm>
-              <a:off x="4806696" y="5443451"/>
-              <a:ext cx="182880" cy="0"/>
+              <a:off x="4815840" y="5295731"/>
+              <a:ext cx="146304" cy="0"/>
             </a:xfrm>
             <a:prstGeom prst="straightConnector1">
               <a:avLst/>
@@ -5078,8 +5078,8 @@
           </p:nvCxnSpPr>
           <p:spPr>
             <a:xfrm>
-              <a:off x="2563368" y="6985185"/>
-              <a:ext cx="182880" cy="0"/>
+              <a:off x="2590800" y="6962648"/>
+              <a:ext cx="146304" cy="0"/>
             </a:xfrm>
             <a:prstGeom prst="straightConnector1">
               <a:avLst/>
@@ -5101,8 +5101,8 @@
           </p:nvCxnSpPr>
           <p:spPr>
             <a:xfrm>
-              <a:off x="4806696" y="6985185"/>
-              <a:ext cx="182880" cy="0"/>
+              <a:off x="4815840" y="6962648"/>
+              <a:ext cx="146304" cy="0"/>
             </a:xfrm>
             <a:prstGeom prst="straightConnector1">
               <a:avLst/>
@@ -5124,8 +5124,8 @@
           </p:nvSpPr>
           <p:spPr>
             <a:xfrm>
-              <a:off x="1533144" y="5930854"/>
-              <a:ext cx="4486656" cy="274320"/>
+              <a:off x="1551432" y="5873157"/>
+              <a:ext cx="4450080" cy="237744"/>
             </a:xfrm>
             <a:custGeom>
               <a:avLst/>
@@ -5134,18 +5134,18 @@
               <a:cxnLst/>
               <a:rect l="l" t="t" r="r" b="b"/>
               <a:pathLst>
-                <a:path w="4486656" h="274320" fill="none">
+                <a:path w="4450080" h="237744" fill="none">
                   <a:moveTo>
-                    <a:pt x="4486656" y="0"/>
+                    <a:pt x="4450080" y="0"/>
                   </a:moveTo>
                   <a:lnTo>
-                    <a:pt x="4486656" y="137160"/>
+                    <a:pt x="4450080" y="118872"/>
                   </a:lnTo>
                   <a:lnTo>
-                    <a:pt x="0" y="137160"/>
+                    <a:pt x="0" y="118872"/>
                   </a:lnTo>
                   <a:lnTo>
-                    <a:pt x="0" y="274320"/>
+                    <a:pt x="0" y="237744"/>
                   </a:lnTo>
                 </a:path>
               </a:pathLst>
@@ -5176,7 +5176,7 @@
         </p:nvSpPr>
         <p:spPr>
           <a:xfrm>
-            <a:off x="548640" y="7710332"/>
+            <a:off x="548640" y="7741243"/>
             <a:ext cx="365760" cy="256032"/>
           </a:xfrm>
           <a:prstGeom prst="roundRect">
@@ -5210,7 +5210,7 @@
         </p:nvSpPr>
         <p:spPr>
           <a:xfrm>
-            <a:off x="548640" y="7710332"/>
+            <a:off x="548640" y="7741243"/>
             <a:ext cx="365760" cy="256032"/>
           </a:xfrm>
           <a:prstGeom prst="rect">
@@ -5252,7 +5252,7 @@
         </p:nvSpPr>
         <p:spPr>
           <a:xfrm>
-            <a:off x="1024128" y="7710332"/>
+            <a:off x="1024128" y="7741243"/>
             <a:ext cx="3840480" cy="256032"/>
           </a:xfrm>
           <a:prstGeom prst="rect">
@@ -5294,7 +5294,7 @@
         </p:nvSpPr>
         <p:spPr>
           <a:xfrm>
-            <a:off x="4626864" y="7710332"/>
+            <a:off x="4626864" y="7741243"/>
             <a:ext cx="2377440" cy="256032"/>
           </a:xfrm>
           <a:prstGeom prst="rect">
@@ -5344,7 +5344,7 @@
         </p:blipFill>
         <p:spPr>
           <a:xfrm>
-            <a:off x="548640" y="8076092"/>
+            <a:off x="548640" y="8088715"/>
             <a:ext cx="1828800" cy="1758361"/>
           </a:xfrm>
           <a:prstGeom prst="rect">
@@ -5360,7 +5360,7 @@
         </p:nvSpPr>
         <p:spPr>
           <a:xfrm>
-            <a:off x="548640" y="9871029"/>
+            <a:off x="548640" y="9883652"/>
             <a:ext cx="1828800" cy="201168"/>
           </a:xfrm>
           <a:prstGeom prst="rect">
@@ -5399,7 +5399,7 @@
         </p:nvSpPr>
         <p:spPr>
           <a:xfrm>
-            <a:off x="2651760" y="8076092"/>
+            <a:off x="2651760" y="8088715"/>
             <a:ext cx="4352544" cy="960120"/>
           </a:xfrm>
           <a:prstGeom prst="rect">
@@ -5467,7 +5467,7 @@
         </p:nvSpPr>
         <p:spPr>
           <a:xfrm>
-            <a:off x="2651760" y="9194373"/>
+            <a:off x="2651760" y="9206996"/>
             <a:ext cx="4352544" cy="640080"/>
           </a:xfrm>
           <a:prstGeom prst="roundRect">
@@ -5501,7 +5501,7 @@
         </p:nvSpPr>
         <p:spPr>
           <a:xfrm>
-            <a:off x="2816352" y="9194373"/>
+            <a:off x="2816352" y="9206996"/>
             <a:ext cx="4023360" cy="640080"/>
           </a:xfrm>
           <a:prstGeom prst="rect">

</xml_diff>

<commit_message>
Re-layout CV slide 5 and note the IEEE Access submission
- Subtitle and a new research-outcome card (mirroring slide 3's award
  card) state that the work has been submitted to IEEE Access.
- Overview figure enlarged from 3.9in to 6.4in wide and no longer
  overlaps the text.
- Text regrouped into motivation, method, role and takeaway; the team
  lead note folds into the role paragraph.
- Photos resized so their captions no longer run past the page number.

Co-Authored-By: Claude Opus 5.5 <noreply@anthropic.com>
Claude-Session: https://claude.ai/code/session_01X2qFQGQaWjMneKihQ62xc2
</commit_message>
<xml_diff>
--- a/CV_updated.pptx
+++ b/CV_updated.pptx
@@ -8937,7 +8937,7 @@
                 <a:ea typeface="Microsoft JhengHei" pitchFamily="34" charset="-120"/>
                 <a:cs typeface="Microsoft JhengHei" pitchFamily="34" charset="-120"/>
               </a:rPr>
-              <a:t>大專生研究計畫  ·  專題組長</a:t>
+              <a:t>大專生研究計畫  ·  專題組長  ·  已投稿 IEEE Access</a:t>
             </a:r>
             <a:endParaRPr lang="zh-TW" altLang="en-US" sz="1050" dirty="0"/>
           </a:p>
@@ -9389,8 +9389,8 @@
         </p:nvSpPr>
         <p:spPr>
           <a:xfrm>
-            <a:off x="548640" y="2496312"/>
-            <a:ext cx="6459322" cy="3040380"/>
+            <a:off x="548640" y="2359152"/>
+            <a:ext cx="6455664" cy="475488"/>
           </a:xfrm>
           <a:prstGeom prst="rect">
             <a:avLst/>
@@ -9420,10 +9420,62 @@
                 <a:ea typeface="Microsoft JhengHei" pitchFamily="34" charset="-120"/>
                 <a:cs typeface="Microsoft JhengHei" pitchFamily="34" charset="-120"/>
               </a:rPr>
-              <a:t>我們想做一個能自動分類的垃圾桶。只靠單一感測器有它的限制，所以同時收集垃圾的影像和碰撞時的聲音，用多模態深度學習提高分類準確率。</a:t>
+              <a:t>我們想做一個能自動分類的垃圾桶。只靠影像有它的限制，像白色的塑膠碗和紙碗外觀幾乎一樣，所以同時收集垃圾的影像和碰撞時的聲音，用多模態深度學習提高分類準確率。</a:t>
             </a:r>
             <a:endParaRPr lang="zh-TW" altLang="en-US" sz="1050" dirty="0"/>
           </a:p>
+        </p:txBody>
+      </p:sp>
+      <p:pic>
+        <p:nvPicPr>
+          <p:cNvPr id="26" name="Overview figure">
+            <a:extLst>
+              <a:ext uri="{FF2B5EF4-FFF2-40B4-BE49-F238E27FC236}">
+                <a16:creationId xmlns:a16="http://schemas.microsoft.com/office/drawing/2014/main" id="{6BD09F2F-EAB0-A942-7093-28A1763FCAEA}"/>
+              </a:ext>
+            </a:extLst>
+          </p:cNvPr>
+          <p:cNvPicPr/>
+          <p:nvPr/>
+        </p:nvPicPr>
+        <p:blipFill>
+          <a:blip r:embed="rId5"/>
+          <a:srcRect/>
+          <a:stretch>
+            <a:fillRect/>
+          </a:stretch>
+        </p:blipFill>
+        <p:spPr>
+          <a:xfrm>
+            <a:off x="850392" y="2926080"/>
+            <a:ext cx="5852160" cy="3193954"/>
+          </a:xfrm>
+          <a:prstGeom prst="rect">
+            <a:avLst/>
+          </a:prstGeom>
+          <a:ln/>
+        </p:spPr>
+      </p:pic>
+      <p:sp>
+        <p:nvSpPr>
+          <p:cNvPr id="27" name="P5_b"/>
+          <p:cNvSpPr txBox="1"/>
+          <p:nvPr/>
+        </p:nvSpPr>
+        <p:spPr>
+          <a:xfrm>
+            <a:off x="548640" y="6266338"/>
+            <a:ext cx="6455664" cy="1645920"/>
+          </a:xfrm>
+          <a:prstGeom prst="rect">
+            <a:avLst/>
+          </a:prstGeom>
+          <a:noFill/>
+          <a:ln/>
+        </p:spPr>
+        <p:txBody>
+          <a:bodyPr wrap="square" lIns="0" tIns="0" rIns="0" bIns="0" rtlCol="0" anchor="t"/>
+          <a:lstStyle/>
           <a:p>
             <a:pPr marL="0" indent="0" eaLnBrk="1" latinLnBrk="0" hangingPunct="1">
               <a:lnSpc>
@@ -9443,7 +9495,7 @@
                 <a:ea typeface="Microsoft JhengHei" pitchFamily="34" charset="-120"/>
                 <a:cs typeface="Microsoft JhengHei" pitchFamily="34" charset="-120"/>
               </a:rPr>
-              <a:t>特徵擷取：</a:t>
+              <a:t>研究方法：</a:t>
             </a:r>
             <a:r>
               <a:rPr lang="zh-TW" altLang="en-US" sz="1050" dirty="0">
@@ -9454,7 +9506,7 @@
                 <a:ea typeface="Microsoft JhengHei" pitchFamily="34" charset="-120"/>
                 <a:cs typeface="Microsoft JhengHei" pitchFamily="34" charset="-120"/>
               </a:rPr>
-              <a:t>影像用電腦視覺模型抽取空間特徵；聲音則轉成梅爾倒頻係數（MFCC），用來分辨不同材質碰撞時的聲音差異。</a:t>
+              <a:t>影像用電腦視覺模型抽取空間特徵；聲音轉成梅爾倒頻係數（MFCC），分辨不同材質碰撞時的聲音差異。再用交叉注意力（Cross-Attention）融合兩種特徵，模型會依情況調整權重：影像模糊時多靠聲音，環境吵雜時多靠影像，分類結果因此比較穩定。</a:t>
             </a:r>
             <a:endParaRPr lang="zh-TW" altLang="en-US" sz="1050" dirty="0"/>
           </a:p>
@@ -9477,7 +9529,7 @@
                 <a:ea typeface="Microsoft JhengHei" pitchFamily="34" charset="-120"/>
                 <a:cs typeface="Microsoft JhengHei" pitchFamily="34" charset="-120"/>
               </a:rPr>
-              <a:t>交叉注意力（Cross-Attention）：</a:t>
+              <a:t>我負責的部分：</a:t>
             </a:r>
             <a:r>
               <a:rPr lang="zh-TW" altLang="en-US" sz="1050" dirty="0">
@@ -9488,7 +9540,7 @@
                 <a:ea typeface="Microsoft JhengHei" pitchFamily="34" charset="-120"/>
                 <a:cs typeface="Microsoft JhengHei" pitchFamily="34" charset="-120"/>
               </a:rPr>
-              <a:t>把影像和聲音兩種特徵融合在一起。模型會依情況調整兩邊的權重：影像模糊時多靠聲音，環境吵雜時多靠影像，分類結果因此比較穩定。</a:t>
+              <a:t>系統架構和各裝置之間的通訊：把軟硬體串起來，將 PyTorch 訓練好的模型移植到邊緣裝置上執行，整個系統的運作流程也圍繞這個模型搭起來。身為組長，也依每個人擅長的部分分工、追進度。</a:t>
             </a:r>
             <a:endParaRPr lang="zh-TW" altLang="en-US" sz="1050" dirty="0"/>
           </a:p>
@@ -9511,7 +9563,7 @@
                 <a:ea typeface="Microsoft JhengHei" pitchFamily="34" charset="-120"/>
                 <a:cs typeface="Microsoft JhengHei" pitchFamily="34" charset="-120"/>
               </a:rPr>
-              <a:t>我負責的部分：</a:t>
+              <a:t>心得：</a:t>
             </a:r>
             <a:r>
               <a:rPr lang="zh-TW" altLang="en-US" sz="1050" dirty="0">
@@ -9522,64 +9574,7 @@
                 <a:ea typeface="Microsoft JhengHei" pitchFamily="34" charset="-120"/>
                 <a:cs typeface="Microsoft JhengHei" pitchFamily="34" charset="-120"/>
               </a:rPr>
-              <a:t>系統架構和各裝置之間的通訊。我把軟硬體串起來，將 PyTorch 訓練好的模型移植到邊緣裝置上執行，整個系統的運作流程也是圍繞這個模型搭起來的。</a:t>
-            </a:r>
-            <a:endParaRPr lang="zh-TW" altLang="en-US" sz="1050" dirty="0"/>
-          </a:p>
-          <a:p>
-            <a:pPr marL="0" indent="0" eaLnBrk="1" latinLnBrk="0" hangingPunct="1">
-              <a:lnSpc>
-                <a:spcPct val="130000"/>
-              </a:lnSpc>
-              <a:spcAft>
-                <a:spcPts val="500"/>
-              </a:spcAft>
-              <a:buNone/>
-            </a:pPr>
-            <a:r>
-              <a:rPr lang="zh-TW" altLang="en-US" sz="1050" b="1" dirty="0">
-                <a:solidFill>
-                  <a:srgbClr val="1F3A5F"/>
-                </a:solidFill>
-                <a:latin typeface="Microsoft JhengHei" pitchFamily="34" charset="0"/>
-                <a:ea typeface="Microsoft JhengHei" pitchFamily="34" charset="-120"/>
-                <a:cs typeface="Microsoft JhengHei" pitchFamily="34" charset="-120"/>
-              </a:rPr>
-              <a:t>心得：</a:t>
-            </a:r>
-            <a:r>
-              <a:rPr lang="zh-TW" altLang="en-US" sz="1050" dirty="0">
-                <a:solidFill>
-                  <a:srgbClr val="1F2933"/>
-                </a:solidFill>
-                <a:latin typeface="Microsoft JhengHei" pitchFamily="34" charset="0"/>
-                <a:ea typeface="Microsoft JhengHei" pitchFamily="34" charset="-120"/>
-                <a:cs typeface="Microsoft JhengHei" pitchFamily="34" charset="-120"/>
-              </a:rPr>
-              <a:t>這是我第一次把深度學習放進實體的機電系統。通訊和架構上遇到很多沒碰過的問題，只能找國內外的論文來讀，一個一個解決。做完這個專題，我比較知道碰到陌生的主題時該怎麼下手：先找資料、讀懂，再拿來用。</a:t>
-            </a:r>
-            <a:endParaRPr lang="zh-TW" altLang="en-US" sz="1050" dirty="0"/>
-          </a:p>
-          <a:p>
-            <a:pPr marL="0" indent="0" eaLnBrk="1" latinLnBrk="0" hangingPunct="1">
-              <a:lnSpc>
-                <a:spcPct val="130000"/>
-              </a:lnSpc>
-              <a:spcAft>
-                <a:spcPts val="500"/>
-              </a:spcAft>
-              <a:buNone/>
-            </a:pPr>
-            <a:r>
-              <a:rPr lang="zh-TW" altLang="en-US" sz="1050" dirty="0">
-                <a:solidFill>
-                  <a:srgbClr val="1F2933"/>
-                </a:solidFill>
-                <a:latin typeface="Microsoft JhengHei" pitchFamily="34" charset="0"/>
-                <a:ea typeface="Microsoft JhengHei" pitchFamily="34" charset="-120"/>
-                <a:cs typeface="Microsoft JhengHei" pitchFamily="34" charset="-120"/>
-              </a:rPr>
-              <a:t>我同時也是組長。時間有限、卡關的地方又多，怎麼跟組員溝通、依每個人擅長的部分分工、追進度，都花了我不少心思。</a:t>
+              <a:t>第一次把深度學習放進實體的機電系統，通訊和架構上遇到很多沒碰過的問題，只能找國內外論文來讀、一個一個解決，也學會碰到陌生主題時先找資料、讀懂，再拿來用。</a:t>
             </a:r>
             <a:endParaRPr lang="zh-TW" altLang="en-US" sz="1050" dirty="0"/>
           </a:p>
@@ -9602,14 +9597,53 @@
         </p:blipFill>
         <p:spPr>
           <a:xfrm>
-            <a:off x="548640" y="7517875"/>
-            <a:ext cx="2419304" cy="2793854"/>
+            <a:off x="548640" y="8076850"/>
+            <a:ext cx="1544037" cy="1783080"/>
           </a:xfrm>
           <a:prstGeom prst="rect">
             <a:avLst/>
           </a:prstGeom>
         </p:spPr>
       </p:pic>
+      <p:sp>
+        <p:nvSpPr>
+          <p:cNvPr id="24" name="Text 20"/>
+          <p:cNvSpPr txBox="1"/>
+          <p:nvPr/>
+        </p:nvSpPr>
+        <p:spPr>
+          <a:xfrm>
+            <a:off x="548640" y="9896506"/>
+            <a:ext cx="1544037" cy="201168"/>
+          </a:xfrm>
+          <a:prstGeom prst="rect">
+            <a:avLst/>
+          </a:prstGeom>
+          <a:noFill/>
+          <a:ln/>
+        </p:spPr>
+        <p:txBody>
+          <a:bodyPr wrap="square" lIns="0" tIns="0" rIns="0" bIns="0" rtlCol="0" anchor="t"/>
+          <a:lstStyle/>
+          <a:p>
+            <a:pPr marL="0" indent="0" algn="ctr" eaLnBrk="1" latinLnBrk="0" hangingPunct="1">
+              <a:buNone/>
+            </a:pPr>
+            <a:r>
+              <a:rPr lang="zh-TW" altLang="en-US" sz="950" dirty="0">
+                <a:solidFill>
+                  <a:srgbClr val="5F6B7A"/>
+                </a:solidFill>
+                <a:latin typeface="Microsoft JhengHei" pitchFamily="34" charset="0"/>
+                <a:ea typeface="Microsoft JhengHei" pitchFamily="34" charset="-120"/>
+                <a:cs typeface="Microsoft JhengHei" pitchFamily="34" charset="-120"/>
+              </a:rPr>
+              <a:t>垃圾桶本體</a:t>
+            </a:r>
+            <a:endParaRPr lang="zh-TW" altLang="en-US" sz="950" dirty="0"/>
+          </a:p>
+        </p:txBody>
+      </p:sp>
       <p:pic>
         <p:nvPicPr>
           <p:cNvPr id="23" name="Image 1" descr="sorter"/>
@@ -9627,8 +9661,8 @@
         </p:blipFill>
         <p:spPr>
           <a:xfrm>
-            <a:off x="3842766" y="7517333"/>
-            <a:ext cx="2476793" cy="2793855"/>
+            <a:off x="2275557" y="8076850"/>
+            <a:ext cx="1580726" cy="1783080"/>
           </a:xfrm>
           <a:prstGeom prst="rect">
             <a:avLst/>
@@ -9637,14 +9671,14 @@
       </p:pic>
       <p:sp>
         <p:nvSpPr>
-          <p:cNvPr id="24" name="Text 20"/>
-          <p:cNvSpPr txBox="1"/>
-          <p:nvPr/>
-        </p:nvSpPr>
-        <p:spPr>
-          <a:xfrm>
-            <a:off x="483297" y="10384882"/>
-            <a:ext cx="2419304" cy="237744"/>
+          <p:cNvPr id="25" name="Text 21"/>
+          <p:cNvSpPr txBox="1"/>
+          <p:nvPr/>
+        </p:nvSpPr>
+        <p:spPr>
+          <a:xfrm>
+            <a:off x="2275557" y="9896506"/>
+            <a:ext cx="1580726" cy="201168"/>
           </a:xfrm>
           <a:prstGeom prst="rect">
             <a:avLst/>
@@ -9668,7 +9702,7 @@
                 <a:ea typeface="Microsoft JhengHei" pitchFamily="34" charset="-120"/>
                 <a:cs typeface="Microsoft JhengHei" pitchFamily="34" charset="-120"/>
               </a:rPr>
-              <a:t>垃圾桶本體</a:t>
+              <a:t>分類機構</a:t>
             </a:r>
             <a:endParaRPr lang="zh-TW" altLang="en-US" sz="950" dirty="0"/>
           </a:p>
@@ -9676,30 +9710,67 @@
       </p:sp>
       <p:sp>
         <p:nvSpPr>
-          <p:cNvPr id="25" name="Text 21"/>
-          <p:cNvSpPr txBox="1"/>
-          <p:nvPr/>
-        </p:nvSpPr>
-        <p:spPr>
-          <a:xfrm>
-            <a:off x="3900261" y="10373782"/>
-            <a:ext cx="2476793" cy="237744"/>
-          </a:xfrm>
-          <a:prstGeom prst="rect">
-            <a:avLst/>
-          </a:prstGeom>
-          <a:noFill/>
-          <a:ln/>
-        </p:spPr>
-        <p:txBody>
-          <a:bodyPr wrap="square" lIns="0" tIns="0" rIns="0" bIns="0" rtlCol="0" anchor="t"/>
-          <a:lstStyle/>
-          <a:p>
-            <a:pPr marL="0" indent="0" algn="ctr" eaLnBrk="1" latinLnBrk="0" hangingPunct="1">
-              <a:buNone/>
-            </a:pPr>
-            <a:r>
-              <a:rPr lang="zh-TW" altLang="en-US" sz="950" dirty="0">
+          <p:cNvPr id="28" name="Outcome card"/>
+          <p:cNvSpPr/>
+          <p:nvPr/>
+        </p:nvSpPr>
+        <p:spPr>
+          <a:xfrm>
+            <a:off x="4130603" y="8076850"/>
+            <a:ext cx="2873701" cy="1783080"/>
+          </a:xfrm>
+          <a:prstGeom prst="rect">
+            <a:avLst/>
+          </a:prstGeom>
+          <a:solidFill>
+            <a:srgbClr val="EEF2F7"/>
+          </a:solidFill>
+          <a:ln w="12700">
+            <a:solidFill>
+              <a:srgbClr val="EEF2F7"/>
+            </a:solidFill>
+          </a:ln>
+        </p:spPr>
+        <p:txBody>
+          <a:bodyPr/>
+          <a:lstStyle/>
+          <a:p>
+            <a:endParaRPr lang="zh-TW" altLang="en-US"/>
+          </a:p>
+        </p:txBody>
+      </p:sp>
+      <p:sp>
+        <p:nvSpPr>
+          <p:cNvPr id="29" name="Outcome text"/>
+          <p:cNvSpPr txBox="1"/>
+          <p:nvPr/>
+        </p:nvSpPr>
+        <p:spPr>
+          <a:xfrm>
+            <a:off x="4331771" y="8204866"/>
+            <a:ext cx="2471365" cy="1527048"/>
+          </a:xfrm>
+          <a:prstGeom prst="rect">
+            <a:avLst/>
+          </a:prstGeom>
+          <a:noFill/>
+          <a:ln/>
+        </p:spPr>
+        <p:txBody>
+          <a:bodyPr wrap="square" lIns="0" tIns="0" rIns="0" bIns="0" rtlCol="0" anchor="ctr"/>
+          <a:lstStyle/>
+          <a:p>
+            <a:pPr marL="0" indent="0" eaLnBrk="1" latinLnBrk="0" hangingPunct="1">
+              <a:lnSpc>
+                <a:spcPct val="115000"/>
+              </a:lnSpc>
+              <a:spcAft>
+                <a:spcPts val="200"/>
+              </a:spcAft>
+              <a:buNone/>
+            </a:pPr>
+            <a:r>
+              <a:rPr lang="zh-TW" altLang="en-US" sz="950" b="1" kern="0" spc="150" dirty="0">
                 <a:solidFill>
                   <a:srgbClr val="5F6B7A"/>
                 </a:solidFill>
@@ -9707,42 +9778,55 @@
                 <a:ea typeface="Microsoft JhengHei" pitchFamily="34" charset="-120"/>
                 <a:cs typeface="Microsoft JhengHei" pitchFamily="34" charset="-120"/>
               </a:rPr>
-              <a:t>分類機構</a:t>
+              <a:t>研究成果</a:t>
             </a:r>
             <a:endParaRPr lang="zh-TW" altLang="en-US" sz="950" dirty="0"/>
           </a:p>
-        </p:txBody>
-      </p:sp>
-      <p:pic>
-        <p:nvPicPr>
-          <p:cNvPr id="26" name="image14.png">
-            <a:extLst>
-              <a:ext uri="{FF2B5EF4-FFF2-40B4-BE49-F238E27FC236}">
-                <a16:creationId xmlns:a16="http://schemas.microsoft.com/office/drawing/2014/main" id="{6BD09F2F-EAB0-A942-7093-28A1763FCAEA}"/>
-              </a:ext>
-            </a:extLst>
-          </p:cNvPr>
-          <p:cNvPicPr/>
-          <p:nvPr/>
-        </p:nvPicPr>
-        <p:blipFill>
-          <a:blip r:embed="rId5"/>
-          <a:srcRect/>
-          <a:stretch>
-            <a:fillRect/>
-          </a:stretch>
-        </p:blipFill>
-        <p:spPr>
-          <a:xfrm>
-            <a:off x="1975727" y="5353050"/>
-            <a:ext cx="3605045" cy="1967538"/>
-          </a:xfrm>
-          <a:prstGeom prst="rect">
-            <a:avLst/>
-          </a:prstGeom>
-          <a:ln/>
-        </p:spPr>
-      </p:pic>
+          <a:p>
+            <a:pPr marL="0" indent="0" eaLnBrk="1" latinLnBrk="0" hangingPunct="1">
+              <a:lnSpc>
+                <a:spcPct val="115000"/>
+              </a:lnSpc>
+              <a:spcAft>
+                <a:spcPts val="300"/>
+              </a:spcAft>
+              <a:buNone/>
+            </a:pPr>
+            <a:r>
+              <a:rPr lang="zh-TW" altLang="en-US" sz="1800" b="1" dirty="0">
+                <a:solidFill>
+                  <a:srgbClr val="1F3A5F"/>
+                </a:solidFill>
+                <a:latin typeface="Microsoft JhengHei" pitchFamily="34" charset="0"/>
+                <a:ea typeface="Microsoft JhengHei" pitchFamily="34" charset="-120"/>
+                <a:cs typeface="Microsoft JhengHei" pitchFamily="34" charset="-120"/>
+              </a:rPr>
+              <a:t>已投稿 IEEE Access</a:t>
+            </a:r>
+            <a:endParaRPr lang="zh-TW" altLang="en-US" sz="1800" dirty="0"/>
+          </a:p>
+          <a:p>
+            <a:pPr marL="0" indent="0" eaLnBrk="1" latinLnBrk="0" hangingPunct="1">
+              <a:lnSpc>
+                <a:spcPct val="125000"/>
+              </a:lnSpc>
+              <a:buNone/>
+            </a:pPr>
+            <a:r>
+              <a:rPr lang="zh-TW" altLang="en-US" sz="1000" dirty="0">
+                <a:solidFill>
+                  <a:srgbClr val="1F2933"/>
+                </a:solidFill>
+                <a:latin typeface="Microsoft JhengHei" pitchFamily="34" charset="0"/>
+                <a:ea typeface="Microsoft JhengHei" pitchFamily="34" charset="-120"/>
+                <a:cs typeface="Microsoft JhengHei" pitchFamily="34" charset="-120"/>
+              </a:rPr>
+              <a:t>這份多模態垃圾分類研究已整理成期刊論文，投稿至 IEEE Access。</a:t>
+            </a:r>
+            <a:endParaRPr lang="zh-TW" altLang="en-US" sz="1000" dirty="0"/>
+          </a:p>
+        </p:txBody>
+      </p:sp>
     </p:spTree>
   </p:cSld>
   <p:clrMapOvr>

</xml_diff>